<commit_message>
add the stage script page and rewrite the brief as an APA paper
</commit_message>
<xml_diff>
--- a/exports/SkillSight.pptx
+++ b/exports/SkillSight.pptx
@@ -4,6 +4,9 @@
   <p:sldMasterIdLst>
     <p:sldMasterId id="2147483648" r:id="rId1"/>
   </p:sldMasterIdLst>
+  <p:notesMasterIdLst>
+    <p:notesMasterId r:id="rId9"/>
+  </p:notesMasterIdLst>
   <p:sldIdLst>
     <p:sldId id="256" r:id="rId2"/>
     <p:sldId id="257" r:id="rId3"/>
@@ -11,10 +14,8 @@
     <p:sldId id="259" r:id="rId5"/>
     <p:sldId id="260" r:id="rId6"/>
     <p:sldId id="261" r:id="rId7"/>
+    <p:sldId id="262" r:id="rId8"/>
   </p:sldIdLst>
-  <p:notesMasterIdLst>
-    <p:notesMasterId r:id="rId8"/>
-  </p:notesMasterIdLst>
   <p:sldSz cx="18288000" cy="10287000"/>
   <p:notesSz cx="10287000" cy="18288000"/>
   <p:defaultTextStyle>
@@ -109,7 +110,159 @@
       </a:defRPr>
     </a:lvl9pPr>
   </p:defaultTextStyle>
+  <p:extLst>
+    <p:ext uri="{EFAFB233-063F-42B5-8137-9DF3F51BA10A}">
+      <p15:sldGuideLst xmlns:p15="http://schemas.microsoft.com/office/powerpoint/2012/main"/>
+    </p:ext>
+  </p:extLst>
 </p:presentation>
+</file>
+
+<file path=ppt/revisionInfo.xml><?xml version="1.0" encoding="utf-8"?>
+<p1510:revInfo xmlns:a="http://schemas.openxmlformats.org/drawingml/2006/main" xmlns:r="http://schemas.openxmlformats.org/officeDocument/2006/relationships" xmlns:p1510="http://schemas.microsoft.com/office/powerpoint/2015/10/main">
+  <p1510:revLst>
+    <p1510:client id="{09BD2AFA-3D7A-4DCB-862F-5334681A181B}" v="2" dt="2026-09-13T06:32:38.194"/>
+  </p1510:revLst>
+</p1510:revInfo>
+</file>
+
+<file path=ppt/changesInfos/changesInfo1.xml><?xml version="1.0" encoding="utf-8"?>
+<pc:chgInfo xmlns:a="http://schemas.openxmlformats.org/drawingml/2006/main" xmlns:r="http://schemas.openxmlformats.org/officeDocument/2006/relationships" xmlns:ac="http://schemas.microsoft.com/office/drawing/2013/main/command" xmlns:pc="http://schemas.microsoft.com/office/powerpoint/2013/main/command">
+  <pc:docChgLst>
+    <pc:chgData name="Mr Aj" userId="6857a7655e0290f7" providerId="LiveId" clId="{1269664D-8E21-4D12-9992-D2CA9025F01D}"/>
+    <pc:docChg chg="custSel addSld modSld sldOrd">
+      <pc:chgData name="Mr Aj" userId="6857a7655e0290f7" providerId="LiveId" clId="{1269664D-8E21-4D12-9992-D2CA9025F01D}" dt="2026-09-13T06:33:14.556" v="134" actId="14100"/>
+      <pc:docMkLst>
+        <pc:docMk/>
+      </pc:docMkLst>
+      <pc:sldChg chg="modSp mod">
+        <pc:chgData name="Mr Aj" userId="6857a7655e0290f7" providerId="LiveId" clId="{1269664D-8E21-4D12-9992-D2CA9025F01D}" dt="2026-09-13T06:29:04.543" v="5" actId="14100"/>
+        <pc:sldMkLst>
+          <pc:docMk/>
+          <pc:sldMk cId="0" sldId="258"/>
+        </pc:sldMkLst>
+        <pc:spChg chg="mod">
+          <ac:chgData name="Mr Aj" userId="6857a7655e0290f7" providerId="LiveId" clId="{1269664D-8E21-4D12-9992-D2CA9025F01D}" dt="2026-09-13T06:29:04.543" v="5" actId="14100"/>
+          <ac:spMkLst>
+            <pc:docMk/>
+            <pc:sldMk cId="0" sldId="258"/>
+            <ac:spMk id="3" creationId="{00000000-0000-0000-0000-000000000000}"/>
+          </ac:spMkLst>
+        </pc:spChg>
+      </pc:sldChg>
+      <pc:sldChg chg="modSp mod">
+        <pc:chgData name="Mr Aj" userId="6857a7655e0290f7" providerId="LiveId" clId="{1269664D-8E21-4D12-9992-D2CA9025F01D}" dt="2026-09-13T06:28:53.886" v="2" actId="14100"/>
+        <pc:sldMkLst>
+          <pc:docMk/>
+          <pc:sldMk cId="0" sldId="260"/>
+        </pc:sldMkLst>
+        <pc:spChg chg="mod">
+          <ac:chgData name="Mr Aj" userId="6857a7655e0290f7" providerId="LiveId" clId="{1269664D-8E21-4D12-9992-D2CA9025F01D}" dt="2026-09-13T06:28:53.886" v="2" actId="14100"/>
+          <ac:spMkLst>
+            <pc:docMk/>
+            <pc:sldMk cId="0" sldId="260"/>
+            <ac:spMk id="3" creationId="{00000000-0000-0000-0000-000000000000}"/>
+          </ac:spMkLst>
+        </pc:spChg>
+      </pc:sldChg>
+      <pc:sldChg chg="delSp modSp add mod ord">
+        <pc:chgData name="Mr Aj" userId="6857a7655e0290f7" providerId="LiveId" clId="{1269664D-8E21-4D12-9992-D2CA9025F01D}" dt="2026-09-13T06:33:14.556" v="134" actId="14100"/>
+        <pc:sldMkLst>
+          <pc:docMk/>
+          <pc:sldMk cId="3577902648" sldId="262"/>
+        </pc:sldMkLst>
+        <pc:spChg chg="mod">
+          <ac:chgData name="Mr Aj" userId="6857a7655e0290f7" providerId="LiveId" clId="{1269664D-8E21-4D12-9992-D2CA9025F01D}" dt="2026-09-13T06:30:41.973" v="65" actId="14100"/>
+          <ac:spMkLst>
+            <pc:docMk/>
+            <pc:sldMk cId="3577902648" sldId="262"/>
+            <ac:spMk id="3" creationId="{A5A59A27-37FF-EF7F-1034-410C72E39F0D}"/>
+          </ac:spMkLst>
+        </pc:spChg>
+        <pc:spChg chg="mod">
+          <ac:chgData name="Mr Aj" userId="6857a7655e0290f7" providerId="LiveId" clId="{1269664D-8E21-4D12-9992-D2CA9025F01D}" dt="2026-09-13T06:33:09.107" v="132" actId="1076"/>
+          <ac:spMkLst>
+            <pc:docMk/>
+            <pc:sldMk cId="3577902648" sldId="262"/>
+            <ac:spMk id="4" creationId="{97698546-F9C7-F70D-7750-1BC89EEA285A}"/>
+          </ac:spMkLst>
+        </pc:spChg>
+        <pc:spChg chg="mod">
+          <ac:chgData name="Mr Aj" userId="6857a7655e0290f7" providerId="LiveId" clId="{1269664D-8E21-4D12-9992-D2CA9025F01D}" dt="2026-09-13T06:33:14.556" v="134" actId="14100"/>
+          <ac:spMkLst>
+            <pc:docMk/>
+            <pc:sldMk cId="3577902648" sldId="262"/>
+            <ac:spMk id="5" creationId="{81F81FF6-8524-41E0-7F88-84371AA2DFAF}"/>
+          </ac:spMkLst>
+        </pc:spChg>
+        <pc:spChg chg="mod">
+          <ac:chgData name="Mr Aj" userId="6857a7655e0290f7" providerId="LiveId" clId="{1269664D-8E21-4D12-9992-D2CA9025F01D}" dt="2026-09-13T06:33:03.886" v="131" actId="1076"/>
+          <ac:spMkLst>
+            <pc:docMk/>
+            <pc:sldMk cId="3577902648" sldId="262"/>
+            <ac:spMk id="6" creationId="{64BCBE2E-6BB5-E28D-A70E-28237DDEA8CD}"/>
+          </ac:spMkLst>
+        </pc:spChg>
+        <pc:spChg chg="del">
+          <ac:chgData name="Mr Aj" userId="6857a7655e0290f7" providerId="LiveId" clId="{1269664D-8E21-4D12-9992-D2CA9025F01D}" dt="2026-09-13T06:30:19.918" v="61" actId="478"/>
+          <ac:spMkLst>
+            <pc:docMk/>
+            <pc:sldMk cId="3577902648" sldId="262"/>
+            <ac:spMk id="7" creationId="{AA465E6B-FEC5-738E-8A6E-B4F64EF4FD0E}"/>
+          </ac:spMkLst>
+        </pc:spChg>
+        <pc:spChg chg="del">
+          <ac:chgData name="Mr Aj" userId="6857a7655e0290f7" providerId="LiveId" clId="{1269664D-8E21-4D12-9992-D2CA9025F01D}" dt="2026-09-13T06:29:56.460" v="20" actId="478"/>
+          <ac:spMkLst>
+            <pc:docMk/>
+            <pc:sldMk cId="3577902648" sldId="262"/>
+            <ac:spMk id="8" creationId="{67CFF362-8A7D-0DCB-6F8E-F7E541675EA6}"/>
+          </ac:spMkLst>
+        </pc:spChg>
+        <pc:spChg chg="del mod">
+          <ac:chgData name="Mr Aj" userId="6857a7655e0290f7" providerId="LiveId" clId="{1269664D-8E21-4D12-9992-D2CA9025F01D}" dt="2026-09-13T06:30:00.406" v="24" actId="478"/>
+          <ac:spMkLst>
+            <pc:docMk/>
+            <pc:sldMk cId="3577902648" sldId="262"/>
+            <ac:spMk id="9" creationId="{13227C56-6596-307B-9588-9D7B649B1D37}"/>
+          </ac:spMkLst>
+        </pc:spChg>
+        <pc:spChg chg="del mod">
+          <ac:chgData name="Mr Aj" userId="6857a7655e0290f7" providerId="LiveId" clId="{1269664D-8E21-4D12-9992-D2CA9025F01D}" dt="2026-09-13T06:29:59.191" v="23" actId="478"/>
+          <ac:spMkLst>
+            <pc:docMk/>
+            <pc:sldMk cId="3577902648" sldId="262"/>
+            <ac:spMk id="10" creationId="{6E406E8D-00A5-B815-A869-263E20D03290}"/>
+          </ac:spMkLst>
+        </pc:spChg>
+        <pc:spChg chg="del">
+          <ac:chgData name="Mr Aj" userId="6857a7655e0290f7" providerId="LiveId" clId="{1269664D-8E21-4D12-9992-D2CA9025F01D}" dt="2026-09-13T06:30:02.038" v="25" actId="478"/>
+          <ac:spMkLst>
+            <pc:docMk/>
+            <pc:sldMk cId="3577902648" sldId="262"/>
+            <ac:spMk id="11" creationId="{AF3DBA55-CC1C-26F3-0A08-59DFF04390D1}"/>
+          </ac:spMkLst>
+        </pc:spChg>
+        <pc:spChg chg="mod">
+          <ac:chgData name="Mr Aj" userId="6857a7655e0290f7" providerId="LiveId" clId="{1269664D-8E21-4D12-9992-D2CA9025F01D}" dt="2026-09-13T06:30:37.447" v="64" actId="1076"/>
+          <ac:spMkLst>
+            <pc:docMk/>
+            <pc:sldMk cId="3577902648" sldId="262"/>
+            <ac:spMk id="12" creationId="{E0FD87FF-FAA9-33A1-3962-112A150ABC9A}"/>
+          </ac:spMkLst>
+        </pc:spChg>
+        <pc:spChg chg="del">
+          <ac:chgData name="Mr Aj" userId="6857a7655e0290f7" providerId="LiveId" clId="{1269664D-8E21-4D12-9992-D2CA9025F01D}" dt="2026-09-13T06:30:28.557" v="62" actId="478"/>
+          <ac:spMkLst>
+            <pc:docMk/>
+            <pc:sldMk cId="3577902648" sldId="262"/>
+            <ac:spMk id="13" creationId="{76009807-808C-453A-A0DD-0CF4766346DA}"/>
+          </ac:spMkLst>
+        </pc:spChg>
+      </pc:sldChg>
+    </pc:docChg>
+  </pc:docChgLst>
+</pc:chgInfo>
 </file>
 
 <file path=ppt/notesMasters/notesMaster1.xml><?xml version="1.0" encoding="utf-8"?>
@@ -134,234 +287,10 @@
           <a:chExt cx="0" cy="0"/>
         </a:xfrm>
       </p:grpSpPr>
-      <p:sp>
-        <p:nvSpPr>
-          <p:cNvPr id="2" name="Header Placeholder 1"/>
-          <p:cNvSpPr>
-            <a:spLocks noGrp="1"/>
-          </p:cNvSpPr>
-          <p:nvPr>
-            <p:ph type="hdr" sz="quarter"/>
-          </p:nvPr>
-        </p:nvSpPr>
-        <p:spPr>
-          <a:xfrm>
-            <a:off x="0" y="0"/>
-            <a:ext cx="2971800" cy="458788"/>
-          </a:xfrm>
-          <a:prstGeom prst="rect">
-            <a:avLst/>
-          </a:prstGeom>
-        </p:spPr>
-        <p:txBody>
-          <a:bodyPr vert="horz" lIns="91440" tIns="45720" rIns="91440" bIns="45720" rtlCol="0"/>
-          <a:lstStyle>
-            <a:lvl1pPr algn="l">
-              <a:defRPr sz="1200"/>
-            </a:lvl1pPr>
-          </a:lstStyle>
-          <a:p>
-            <a:endParaRPr lang="en-US"/>
-          </a:p>
-        </p:txBody>
-      </p:sp>
-      <p:sp>
-        <p:nvSpPr>
-          <p:cNvPr id="3" name="Date Placeholder 2"/>
-          <p:cNvSpPr>
-            <a:spLocks noGrp="1"/>
-          </p:cNvSpPr>
-          <p:nvPr>
-            <p:ph type="dt" idx="1"/>
-          </p:nvPr>
-        </p:nvSpPr>
-        <p:spPr>
-          <a:xfrm>
-            <a:off x="3884613" y="0"/>
-            <a:ext cx="2971800" cy="458788"/>
-          </a:xfrm>
-          <a:prstGeom prst="rect">
-            <a:avLst/>
-          </a:prstGeom>
-        </p:spPr>
-        <p:txBody>
-          <a:bodyPr vert="horz" lIns="91440" tIns="45720" rIns="91440" bIns="45720" rtlCol="0"/>
-          <a:lstStyle>
-            <a:lvl1pPr algn="r">
-              <a:defRPr sz="1200"/>
-            </a:lvl1pPr>
-          </a:lstStyle>
-          <a:p>
-            <a:fld id="{5282F153-3F37-0F45-9E97-73ACFA13230C}" type="datetimeFigureOut">
-              <a:rPr lang="en-US"/>
-              <a:t>7/23/19</a:t>
-            </a:fld>
-            <a:endParaRPr lang="en-US"/>
-          </a:p>
-        </p:txBody>
-      </p:sp>
-      <p:sp>
-        <p:nvSpPr>
-          <p:cNvPr id="4" name="Slide Image Placeholder 3"/>
-          <p:cNvSpPr>
-            <a:spLocks noGrp="1" noRot="1" noChangeAspect="1"/>
-          </p:cNvSpPr>
-          <p:nvPr>
-            <p:ph type="sldImg" idx="2"/>
-          </p:nvPr>
-        </p:nvSpPr>
-        <p:spPr>
-          <a:xfrm>
-            <a:off x="685800" y="1143000"/>
-            <a:ext cx="5486400" cy="3086100"/>
-          </a:xfrm>
-          <a:prstGeom prst="rect">
-            <a:avLst/>
-          </a:prstGeom>
-          <a:noFill/>
-          <a:ln w="12700">
-            <a:solidFill>
-              <a:prstClr val="black"/>
-            </a:solidFill>
-          </a:ln>
-        </p:spPr>
-        <p:txBody>
-          <a:bodyPr vert="horz" lIns="91440" tIns="45720" rIns="91440" bIns="45720" rtlCol="0" anchor="ctr"/>
-          <a:lstStyle/>
-          <a:p>
-            <a:endParaRPr lang="en-US"/>
-          </a:p>
-        </p:txBody>
-      </p:sp>
-      <p:sp>
-        <p:nvSpPr>
-          <p:cNvPr id="5" name="Notes Placeholder 4"/>
-          <p:cNvSpPr>
-            <a:spLocks noGrp="1"/>
-          </p:cNvSpPr>
-          <p:nvPr>
-            <p:ph type="body" sz="quarter" idx="3"/>
-          </p:nvPr>
-        </p:nvSpPr>
-        <p:spPr>
-          <a:xfrm>
-            <a:off x="685800" y="4400550"/>
-            <a:ext cx="5486400" cy="3600450"/>
-          </a:xfrm>
-          <a:prstGeom prst="rect">
-            <a:avLst/>
-          </a:prstGeom>
-        </p:spPr>
-        <p:txBody>
-          <a:bodyPr vert="horz" lIns="91440" tIns="45720" rIns="91440" bIns="45720" rtlCol="0"/>
-          <a:lstStyle/>
-          <a:p>
-            <a:pPr lvl="0"/>
-            <a:r>
-              <a:rPr lang="en-US"/>
-              <a:t>Click to edit Master text styles</a:t>
-            </a:r>
-          </a:p>
-          <a:p>
-            <a:pPr lvl="1"/>
-            <a:r>
-              <a:rPr lang="en-US"/>
-              <a:t>Second level</a:t>
-            </a:r>
-          </a:p>
-          <a:p>
-            <a:pPr lvl="2"/>
-            <a:r>
-              <a:rPr lang="en-US"/>
-              <a:t>Third level</a:t>
-            </a:r>
-          </a:p>
-          <a:p>
-            <a:pPr lvl="3"/>
-            <a:r>
-              <a:rPr lang="en-US"/>
-              <a:t>Fourth level</a:t>
-            </a:r>
-          </a:p>
-          <a:p>
-            <a:pPr lvl="4"/>
-            <a:r>
-              <a:rPr lang="en-US"/>
-              <a:t>Fifth level</a:t>
-            </a:r>
-          </a:p>
-        </p:txBody>
-      </p:sp>
-      <p:sp>
-        <p:nvSpPr>
-          <p:cNvPr id="6" name="Footer Placeholder 5"/>
-          <p:cNvSpPr>
-            <a:spLocks noGrp="1"/>
-          </p:cNvSpPr>
-          <p:nvPr>
-            <p:ph type="ftr" sz="quarter" idx="4"/>
-          </p:nvPr>
-        </p:nvSpPr>
-        <p:spPr>
-          <a:xfrm>
-            <a:off x="0" y="8685213"/>
-            <a:ext cx="2971800" cy="458787"/>
-          </a:xfrm>
-          <a:prstGeom prst="rect">
-            <a:avLst/>
-          </a:prstGeom>
-        </p:spPr>
-        <p:txBody>
-          <a:bodyPr vert="horz" lIns="91440" tIns="45720" rIns="91440" bIns="45720" rtlCol="0" anchor="b"/>
-          <a:lstStyle>
-            <a:lvl1pPr algn="l">
-              <a:defRPr sz="1200"/>
-            </a:lvl1pPr>
-          </a:lstStyle>
-          <a:p>
-            <a:endParaRPr lang="en-US"/>
-          </a:p>
-        </p:txBody>
-      </p:sp>
-      <p:sp>
-        <p:nvSpPr>
-          <p:cNvPr id="7" name="Slide Number Placeholder 6"/>
-          <p:cNvSpPr>
-            <a:spLocks noGrp="1"/>
-          </p:cNvSpPr>
-          <p:nvPr>
-            <p:ph type="sldNum" sz="quarter" idx="5"/>
-          </p:nvPr>
-        </p:nvSpPr>
-        <p:spPr>
-          <a:xfrm>
-            <a:off x="3884613" y="8685213"/>
-            <a:ext cx="2971800" cy="458787"/>
-          </a:xfrm>
-          <a:prstGeom prst="rect">
-            <a:avLst/>
-          </a:prstGeom>
-        </p:spPr>
-        <p:txBody>
-          <a:bodyPr vert="horz" lIns="91440" tIns="45720" rIns="91440" bIns="45720" rtlCol="0" anchor="b"/>
-          <a:lstStyle>
-            <a:lvl1pPr algn="r">
-              <a:defRPr sz="1200"/>
-            </a:lvl1pPr>
-          </a:lstStyle>
-          <a:p>
-            <a:fld id="{CE5E9CC1-C706-0F49-92D6-E571CC5EEA8F}" type="slidenum">
-              <a:rPr lang="en-US"/>
-              <a:t>‹#›</a:t>
-            </a:fld>
-            <a:endParaRPr lang="en-US"/>
-          </a:p>
-        </p:txBody>
-      </p:sp>
     </p:spTree>
     <p:extLst>
       <p:ext uri="{BB962C8B-B14F-4D97-AF65-F5344CB8AC3E}">
-        <p14:creationId xmlns:p14="http://schemas.microsoft.com/office/powerpoint/2010/main" val="1024086991"/>
+        <p14:creationId xmlns:p14="http://schemas.microsoft.com/office/powerpoint/2010/main" val="3126431070"/>
       </p:ext>
     </p:extLst>
   </p:cSld>
@@ -511,7 +440,6 @@
 "SkillSight. It shows what skills Schwan's people have, where those skills are missing, and where one person leaving stops the work."
 Do not read the numbers out. Let them sit on the slide. Move on at fifteen seconds.</a:t>
             </a:r>
-            <a:endParaRPr lang="en-US" dirty="0"/>
           </a:p>
         </p:txBody>
       </p:sp>
@@ -602,7 +530,6 @@
 "But ask a simple question. If the person who knows the ammonia refrigeration system leaves, who else can do it? Today that answer takes phone calls to three plants."
 Point at the zero. That is the whole problem in one number.</a:t>
             </a:r>
-            <a:endParaRPr lang="en-US" dirty="0"/>
           </a:p>
         </p:txBody>
       </p:sp>
@@ -693,7 +620,6 @@
 "Two of these are ammonia refrigeration techs who are close to retirement. That one is not guesswork. Ammonia systems over ten thousand pounds are an OSHA covered process, so the list of trained operators is kept by law. The data already exists."
 Slow down here. This is the slide people remember.</a:t>
             </a:r>
-            <a:endParaRPr lang="en-US" dirty="0"/>
           </a:p>
         </p:txBody>
       </p:sp>
@@ -785,7 +711,6 @@
 "Each step is one of the five methods the challenge names. Training, mentoring, certification, job rotation, project experience."
 If you are demoing live, this is where you switch to the app and tick one plan box.</a:t>
             </a:r>
-            <a:endParaRPr lang="en-US" dirty="0"/>
           </a:p>
         </p:txBody>
       </p:sp>
@@ -876,7 +801,6 @@
 "Sam is a refrigeration tech at Marshall, fourteen years in. He is one of two people who hold the ammonia certification, so his step is to pass it on. He ticks the same box his manager sees."
 If demoing: tick the box, show the counter go to one, then say the next line.</a:t>
             </a:r>
-            <a:endParaRPr lang="en-US" dirty="0"/>
           </a:p>
         </p:txBody>
       </p:sp>
@@ -969,7 +893,6 @@
 Leave this slide up. It is your prompt sheet: the four answers are on it.
 If asked something not here: "I do not know, and I would rather find out than guess."</a:t>
             </a:r>
-            <a:endParaRPr lang="en-US" dirty="0"/>
           </a:p>
         </p:txBody>
       </p:sp>
@@ -1000,6 +923,119 @@
     <p:extLst>
       <p:ext uri="{BB962C8B-B14F-4D97-AF65-F5344CB8AC3E}">
         <p14:creationId xmlns:p14="http://schemas.microsoft.com/office/powerpoint/2010/main" val="1024086991"/>
+      </p:ext>
+    </p:extLst>
+  </p:cSld>
+  <p:clrMapOvr>
+    <a:masterClrMapping/>
+  </p:clrMapOvr>
+</p:notes>
+</file>
+
+<file path=ppt/notesSlides/notesSlide7.xml><?xml version="1.0" encoding="utf-8"?>
+<p:notes xmlns:a="http://schemas.openxmlformats.org/drawingml/2006/main" xmlns:r="http://schemas.openxmlformats.org/officeDocument/2006/relationships" xmlns:p="http://schemas.openxmlformats.org/presentationml/2006/main">
+  <p:cSld>
+    <p:spTree>
+      <p:nvGrpSpPr>
+        <p:cNvPr id="1" name="">
+          <a:extLst>
+            <a:ext uri="{FF2B5EF4-FFF2-40B4-BE49-F238E27FC236}">
+              <a16:creationId xmlns:a16="http://schemas.microsoft.com/office/drawing/2014/main" id="{28911E06-F609-1945-23E1-DA98416278F5}"/>
+            </a:ext>
+          </a:extLst>
+        </p:cNvPr>
+        <p:cNvGrpSpPr/>
+        <p:nvPr/>
+      </p:nvGrpSpPr>
+      <p:grpSpPr>
+        <a:xfrm>
+          <a:off x="0" y="0"/>
+          <a:ext cx="0" cy="0"/>
+          <a:chOff x="0" y="0"/>
+          <a:chExt cx="0" cy="0"/>
+        </a:xfrm>
+      </p:grpSpPr>
+      <p:sp>
+        <p:nvSpPr>
+          <p:cNvPr id="2" name="Slide Image Placeholder 1">
+            <a:extLst>
+              <a:ext uri="{FF2B5EF4-FFF2-40B4-BE49-F238E27FC236}">
+                <a16:creationId xmlns:a16="http://schemas.microsoft.com/office/drawing/2014/main" id="{C11508D2-C296-3122-51AB-EFAC8792C9E4}"/>
+              </a:ext>
+            </a:extLst>
+          </p:cNvPr>
+          <p:cNvSpPr>
+            <a:spLocks noGrp="1" noRot="1" noChangeAspect="1"/>
+          </p:cNvSpPr>
+          <p:nvPr>
+            <p:ph type="sldImg"/>
+          </p:nvPr>
+        </p:nvSpPr>
+        <p:spPr/>
+      </p:sp>
+      <p:sp>
+        <p:nvSpPr>
+          <p:cNvPr id="3" name="Notes Placeholder 2">
+            <a:extLst>
+              <a:ext uri="{FF2B5EF4-FFF2-40B4-BE49-F238E27FC236}">
+                <a16:creationId xmlns:a16="http://schemas.microsoft.com/office/drawing/2014/main" id="{10C2F6F7-6768-AAAA-7C8B-BD66A7E6F7AE}"/>
+              </a:ext>
+            </a:extLst>
+          </p:cNvPr>
+          <p:cNvSpPr>
+            <a:spLocks noGrp="1"/>
+          </p:cNvSpPr>
+          <p:nvPr>
+            <p:ph type="body" idx="1"/>
+          </p:nvPr>
+        </p:nvSpPr>
+        <p:spPr/>
+        <p:txBody>
+          <a:bodyPr/>
+          <a:lstStyle/>
+          <a:p>
+            <a:r>
+              <a:rPr lang="en-US" dirty="0"/>
+              <a:t>0:00 to 0:15  OPENER
+"SkillSight. It shows what skills Schwan's people have, where those skills are missing, and where one person leaving stops the work."
+Do not read the numbers out. Let them sit on the slide. Move on at fifteen seconds.</a:t>
+            </a:r>
+          </a:p>
+        </p:txBody>
+      </p:sp>
+      <p:sp>
+        <p:nvSpPr>
+          <p:cNvPr id="4" name="Slide Number Placeholder 3">
+            <a:extLst>
+              <a:ext uri="{FF2B5EF4-FFF2-40B4-BE49-F238E27FC236}">
+                <a16:creationId xmlns:a16="http://schemas.microsoft.com/office/drawing/2014/main" id="{0DBE8ED7-A24F-90D0-B003-451D820B499B}"/>
+              </a:ext>
+            </a:extLst>
+          </p:cNvPr>
+          <p:cNvSpPr>
+            <a:spLocks noGrp="1"/>
+          </p:cNvSpPr>
+          <p:nvPr>
+            <p:ph type="sldNum" sz="quarter" idx="10"/>
+          </p:nvPr>
+        </p:nvSpPr>
+        <p:spPr/>
+        <p:txBody>
+          <a:bodyPr/>
+          <a:lstStyle/>
+          <a:p>
+            <a:fld id="{F7021451-1387-4CA6-816F-3879F97B5CBC}" type="slidenum">
+              <a:rPr lang="en-US"/>
+              <a:t>7</a:t>
+            </a:fld>
+            <a:endParaRPr lang="en-US"/>
+          </a:p>
+        </p:txBody>
+      </p:sp>
+    </p:spTree>
+    <p:extLst>
+      <p:ext uri="{BB962C8B-B14F-4D97-AF65-F5344CB8AC3E}">
+        <p14:creationId xmlns:p14="http://schemas.microsoft.com/office/powerpoint/2010/main" val="2960918742"/>
       </p:ext>
     </p:extLst>
   </p:cSld>
@@ -1042,6 +1078,11 @@
 <file path=ppt/slideMasters/slideMaster1.xml><?xml version="1.0" encoding="utf-8"?>
 <p:sldMaster xmlns:a="http://schemas.openxmlformats.org/drawingml/2006/main" xmlns:r="http://schemas.openxmlformats.org/officeDocument/2006/relationships" xmlns:p="http://schemas.openxmlformats.org/presentationml/2006/main">
   <p:cSld>
+    <p:bg>
+      <p:bgRef idx="1001">
+        <a:schemeClr val="bg1"/>
+      </p:bgRef>
+    </p:bg>
     <p:spTree>
       <p:nvGrpSpPr>
         <p:cNvPr id="1" name=""/>
@@ -1357,6 +1398,13 @@
             <a:prstDash val="solid"/>
           </a:ln>
         </p:spPr>
+        <p:txBody>
+          <a:bodyPr/>
+          <a:lstStyle/>
+          <a:p>
+            <a:endParaRPr lang="en-US"/>
+          </a:p>
+        </p:txBody>
       </p:sp>
       <p:sp>
         <p:nvSpPr>
@@ -1382,6 +1430,13 @@
             <a:prstDash val="solid"/>
           </a:ln>
         </p:spPr>
+        <p:txBody>
+          <a:bodyPr/>
+          <a:lstStyle/>
+          <a:p>
+            <a:endParaRPr lang="en-US"/>
+          </a:p>
+        </p:txBody>
       </p:sp>
       <p:sp>
         <p:nvSpPr>
@@ -1404,7 +1459,7 @@
           <a:bodyPr wrap="square" lIns="0" tIns="0" rIns="0" bIns="0" rtlCol="0" anchor="ctr"/>
           <a:lstStyle/>
           <a:p>
-            <a:pPr indent="0" marL="0">
+            <a:pPr marL="0" indent="0">
               <a:lnSpc>
                 <a:spcPct val="90000"/>
               </a:lnSpc>
@@ -1447,6 +1502,13 @@
             <a:prstDash val="solid"/>
           </a:ln>
         </p:spPr>
+        <p:txBody>
+          <a:bodyPr/>
+          <a:lstStyle/>
+          <a:p>
+            <a:endParaRPr lang="en-US"/>
+          </a:p>
+        </p:txBody>
       </p:sp>
       <p:sp>
         <p:nvSpPr>
@@ -1469,11 +1531,11 @@
           <a:bodyPr wrap="square" lIns="0" tIns="0" rIns="0" bIns="0" rtlCol="0" anchor="ctr"/>
           <a:lstStyle/>
           <a:p>
-            <a:pPr indent="0" marL="0">
-              <a:buNone/>
-            </a:pPr>
-            <a:r>
-              <a:rPr lang="en-US" sz="2000" b="1" spc="600" kern="0" dirty="0">
+            <a:pPr marL="0" indent="0">
+              <a:buNone/>
+            </a:pPr>
+            <a:r>
+              <a:rPr lang="en-US" sz="2000" b="1" kern="0" spc="600" dirty="0">
                 <a:solidFill>
                   <a:srgbClr val="FFFFFF"/>
                 </a:solidFill>
@@ -1508,7 +1570,7 @@
           <a:bodyPr wrap="square" lIns="0" tIns="0" rIns="0" bIns="0" rtlCol="0" anchor="ctr"/>
           <a:lstStyle/>
           <a:p>
-            <a:pPr indent="0" marL="0">
+            <a:pPr marL="0" indent="0">
               <a:lnSpc>
                 <a:spcPct val="135000"/>
               </a:lnSpc>
@@ -1528,7 +1590,7 @@
             <a:endParaRPr lang="en-US" sz="2100" dirty="0"/>
           </a:p>
           <a:p>
-            <a:pPr indent="0" marL="0">
+            <a:pPr marL="0" indent="0">
               <a:lnSpc>
                 <a:spcPct val="135000"/>
               </a:lnSpc>
@@ -1570,7 +1632,7 @@
           <a:bodyPr wrap="square" lIns="0" tIns="0" rIns="0" bIns="0" rtlCol="0" anchor="ctr"/>
           <a:lstStyle/>
           <a:p>
-            <a:pPr algn="r" indent="0" marL="0">
+            <a:pPr marL="0" indent="0" algn="r">
               <a:buNone/>
             </a:pPr>
             <a:r>
@@ -1609,11 +1671,11 @@
           <a:bodyPr wrap="square" lIns="0" tIns="0" rIns="0" bIns="0" rtlCol="0" anchor="ctr"/>
           <a:lstStyle/>
           <a:p>
-            <a:pPr algn="r" indent="0" marL="0">
-              <a:buNone/>
-            </a:pPr>
-            <a:r>
-              <a:rPr lang="en-US" sz="1300" spc="200" kern="0" dirty="0">
+            <a:pPr marL="0" indent="0" algn="r">
+              <a:buNone/>
+            </a:pPr>
+            <a:r>
+              <a:rPr lang="en-US" sz="1300" kern="0" spc="200" dirty="0">
                 <a:solidFill>
                   <a:srgbClr val="44528A"/>
                 </a:solidFill>
@@ -1648,7 +1710,7 @@
           <a:bodyPr wrap="square" lIns="0" tIns="0" rIns="0" bIns="0" rtlCol="0" anchor="ctr"/>
           <a:lstStyle/>
           <a:p>
-            <a:pPr algn="r" indent="0" marL="0">
+            <a:pPr marL="0" indent="0" algn="r">
               <a:buNone/>
             </a:pPr>
             <a:r>
@@ -1687,11 +1749,11 @@
           <a:bodyPr wrap="square" lIns="0" tIns="0" rIns="0" bIns="0" rtlCol="0" anchor="ctr"/>
           <a:lstStyle/>
           <a:p>
-            <a:pPr algn="r" indent="0" marL="0">
-              <a:buNone/>
-            </a:pPr>
-            <a:r>
-              <a:rPr lang="en-US" sz="1300" spc="200" kern="0" dirty="0">
+            <a:pPr marL="0" indent="0" algn="r">
+              <a:buNone/>
+            </a:pPr>
+            <a:r>
+              <a:rPr lang="en-US" sz="1300" kern="0" spc="200" dirty="0">
                 <a:solidFill>
                   <a:srgbClr val="44528A"/>
                 </a:solidFill>
@@ -1726,11 +1788,11 @@
           <a:bodyPr wrap="square" lIns="0" tIns="0" rIns="0" bIns="0" rtlCol="0" anchor="ctr"/>
           <a:lstStyle/>
           <a:p>
-            <a:pPr indent="0" marL="0">
-              <a:buNone/>
-            </a:pPr>
-            <a:r>
-              <a:rPr lang="en-US" sz="1300" b="1" spc="300" kern="0" dirty="0">
+            <a:pPr marL="0" indent="0">
+              <a:buNone/>
+            </a:pPr>
+            <a:r>
+              <a:rPr lang="en-US" sz="1300" b="1" kern="0" spc="300" dirty="0">
                 <a:solidFill>
                   <a:srgbClr val="8E98AE"/>
                 </a:solidFill>
@@ -1765,7 +1827,7 @@
           <a:bodyPr wrap="square" lIns="0" tIns="0" rIns="0" bIns="0" rtlCol="0" anchor="ctr"/>
           <a:lstStyle/>
           <a:p>
-            <a:pPr indent="0" marL="0">
+            <a:pPr marL="0" indent="0">
               <a:buNone/>
             </a:pPr>
             <a:r>
@@ -1829,11 +1891,11 @@
           <a:bodyPr wrap="square" lIns="0" tIns="0" rIns="0" bIns="0" rtlCol="0" anchor="ctr"/>
           <a:lstStyle/>
           <a:p>
-            <a:pPr indent="0" marL="0">
-              <a:buNone/>
-            </a:pPr>
-            <a:r>
-              <a:rPr lang="en-US" sz="1300" b="1" spc="300" kern="0" dirty="0">
+            <a:pPr marL="0" indent="0">
+              <a:buNone/>
+            </a:pPr>
+            <a:r>
+              <a:rPr lang="en-US" sz="1300" b="1" kern="0" spc="300" dirty="0">
                 <a:solidFill>
                   <a:srgbClr val="6E7788"/>
                 </a:solidFill>
@@ -1868,7 +1930,7 @@
           <a:bodyPr wrap="square" lIns="0" tIns="0" rIns="0" bIns="0" rtlCol="0" anchor="ctr"/>
           <a:lstStyle/>
           <a:p>
-            <a:pPr indent="0" marL="0">
+            <a:pPr marL="0" indent="0">
               <a:lnSpc>
                 <a:spcPct val="106000"/>
               </a:lnSpc>
@@ -1888,7 +1950,7 @@
             <a:endParaRPr lang="en-US" sz="4400" dirty="0"/>
           </a:p>
           <a:p>
-            <a:pPr indent="0" marL="0">
+            <a:pPr marL="0" indent="0">
               <a:lnSpc>
                 <a:spcPct val="106000"/>
               </a:lnSpc>
@@ -1930,7 +1992,7 @@
           <a:bodyPr wrap="square" lIns="0" tIns="0" rIns="0" bIns="0" rtlCol="0" anchor="ctr"/>
           <a:lstStyle/>
           <a:p>
-            <a:pPr indent="0" marL="0">
+            <a:pPr marL="0" indent="0">
               <a:lnSpc>
                 <a:spcPct val="120000"/>
               </a:lnSpc>
@@ -1950,7 +2012,7 @@
             <a:endParaRPr lang="en-US" sz="3400" dirty="0"/>
           </a:p>
           <a:p>
-            <a:pPr indent="0" marL="0">
+            <a:pPr marL="0" indent="0">
               <a:lnSpc>
                 <a:spcPct val="120000"/>
               </a:lnSpc>
@@ -1992,7 +2054,7 @@
           <a:bodyPr wrap="square" lIns="0" tIns="0" rIns="0" bIns="0" rtlCol="0" anchor="ctr"/>
           <a:lstStyle/>
           <a:p>
-            <a:pPr indent="0" marL="0">
+            <a:pPr marL="0" indent="0">
               <a:buNone/>
             </a:pPr>
             <a:r>
@@ -2032,6 +2094,13 @@
             <a:prstDash val="solid"/>
           </a:ln>
         </p:spPr>
+        <p:txBody>
+          <a:bodyPr/>
+          <a:lstStyle/>
+          <a:p>
+            <a:endParaRPr lang="en-US"/>
+          </a:p>
+        </p:txBody>
       </p:sp>
       <p:sp>
         <p:nvSpPr>
@@ -2054,7 +2123,7 @@
           <a:bodyPr wrap="square" lIns="0" tIns="0" rIns="0" bIns="0" rtlCol="0" anchor="ctr"/>
           <a:lstStyle/>
           <a:p>
-            <a:pPr indent="0" marL="0">
+            <a:pPr marL="0" indent="0">
               <a:buNone/>
             </a:pPr>
             <a:r>
@@ -2093,7 +2162,7 @@
           <a:bodyPr wrap="square" lIns="0" tIns="0" rIns="0" bIns="0" rtlCol="0" anchor="ctr"/>
           <a:lstStyle/>
           <a:p>
-            <a:pPr indent="0" marL="0">
+            <a:pPr marL="0" indent="0">
               <a:buNone/>
             </a:pPr>
             <a:r>
@@ -2132,7 +2201,7 @@
           <a:bodyPr wrap="square" lIns="0" tIns="0" rIns="0" bIns="0" rtlCol="0" anchor="ctr"/>
           <a:lstStyle/>
           <a:p>
-            <a:pPr indent="0" marL="0">
+            <a:pPr marL="0" indent="0">
               <a:buNone/>
             </a:pPr>
             <a:r>
@@ -2171,7 +2240,7 @@
           <a:bodyPr wrap="square" lIns="0" tIns="0" rIns="0" bIns="0" rtlCol="0" anchor="ctr"/>
           <a:lstStyle/>
           <a:p>
-            <a:pPr indent="0" marL="0">
+            <a:pPr marL="0" indent="0">
               <a:buNone/>
             </a:pPr>
             <a:r>
@@ -2210,7 +2279,7 @@
           <a:bodyPr wrap="square" lIns="0" tIns="0" rIns="0" bIns="0" rtlCol="0" anchor="ctr"/>
           <a:lstStyle/>
           <a:p>
-            <a:pPr indent="0" marL="0">
+            <a:pPr marL="0" indent="0">
               <a:buNone/>
             </a:pPr>
             <a:r>
@@ -2249,7 +2318,7 @@
           <a:bodyPr wrap="square" lIns="0" tIns="0" rIns="0" bIns="0" rtlCol="0" anchor="ctr"/>
           <a:lstStyle/>
           <a:p>
-            <a:pPr indent="0" marL="0">
+            <a:pPr marL="0" indent="0">
               <a:buNone/>
             </a:pPr>
             <a:r>
@@ -2288,7 +2357,7 @@
           <a:bodyPr wrap="square" lIns="0" tIns="0" rIns="0" bIns="0" rtlCol="0" anchor="ctr"/>
           <a:lstStyle/>
           <a:p>
-            <a:pPr indent="0" marL="0">
+            <a:pPr marL="0" indent="0">
               <a:buNone/>
             </a:pPr>
             <a:r>
@@ -2327,7 +2396,7 @@
           <a:bodyPr wrap="square" lIns="0" tIns="0" rIns="0" bIns="0" rtlCol="0" anchor="ctr"/>
           <a:lstStyle/>
           <a:p>
-            <a:pPr indent="0" marL="0">
+            <a:pPr marL="0" indent="0">
               <a:buNone/>
             </a:pPr>
             <a:r>
@@ -2367,6 +2436,13 @@
             <a:prstDash val="solid"/>
           </a:ln>
         </p:spPr>
+        <p:txBody>
+          <a:bodyPr/>
+          <a:lstStyle/>
+          <a:p>
+            <a:endParaRPr lang="en-US"/>
+          </a:p>
+        </p:txBody>
       </p:sp>
       <p:sp>
         <p:nvSpPr>
@@ -2389,11 +2465,11 @@
           <a:bodyPr wrap="square" lIns="0" tIns="0" rIns="0" bIns="0" rtlCol="0" anchor="ctr"/>
           <a:lstStyle/>
           <a:p>
-            <a:pPr indent="0" marL="0">
-              <a:buNone/>
-            </a:pPr>
-            <a:r>
-              <a:rPr lang="en-US" sz="1400" b="1" spc="200" kern="0" dirty="0">
+            <a:pPr marL="0" indent="0">
+              <a:buNone/>
+            </a:pPr>
+            <a:r>
+              <a:rPr lang="en-US" sz="1400" b="1" kern="0" spc="200" dirty="0">
                 <a:solidFill>
                   <a:srgbClr val="6E7788"/>
                 </a:solidFill>
@@ -2403,9 +2479,6 @@
               </a:rPr>
               <a:t>IN THE APP   </a:t>
             </a:r>
-            <a:pPr indent="0" marL="0">
-              <a:buNone/>
-            </a:pPr>
             <a:r>
               <a:rPr lang="en-US" sz="1400" dirty="0">
                 <a:solidFill>
@@ -2442,11 +2515,11 @@
           <a:bodyPr wrap="square" lIns="0" tIns="0" rIns="0" bIns="0" rtlCol="0" anchor="ctr"/>
           <a:lstStyle/>
           <a:p>
-            <a:pPr indent="0" marL="0">
-              <a:buNone/>
-            </a:pPr>
-            <a:r>
-              <a:rPr lang="en-US" sz="1400" b="1" spc="200" kern="0" dirty="0">
+            <a:pPr marL="0" indent="0">
+              <a:buNone/>
+            </a:pPr>
+            <a:r>
+              <a:rPr lang="en-US" sz="1400" b="1" kern="0" spc="200" dirty="0">
                 <a:solidFill>
                   <a:srgbClr val="6E7788"/>
                 </a:solidFill>
@@ -2456,9 +2529,6 @@
               </a:rPr>
               <a:t>NUMBERS FROM   </a:t>
             </a:r>
-            <a:pPr indent="0" marL="0">
-              <a:buNone/>
-            </a:pPr>
             <a:r>
               <a:rPr lang="en-US" sz="1400" dirty="0">
                 <a:solidFill>
@@ -2523,6 +2593,13 @@
             <a:prstDash val="solid"/>
           </a:ln>
         </p:spPr>
+        <p:txBody>
+          <a:bodyPr/>
+          <a:lstStyle/>
+          <a:p>
+            <a:endParaRPr lang="en-US"/>
+          </a:p>
+        </p:txBody>
       </p:sp>
       <p:sp>
         <p:nvSpPr>
@@ -2532,8 +2609,8 @@
         </p:nvSpPr>
         <p:spPr>
           <a:xfrm>
-            <a:off x="10607040" y="-365760"/>
-            <a:ext cx="8229600" cy="10972800"/>
+            <a:off x="10607040" y="0"/>
+            <a:ext cx="7680960" cy="10286999"/>
           </a:xfrm>
           <a:prstGeom prst="rect">
             <a:avLst/>
@@ -2548,6 +2625,13 @@
             <a:prstDash val="solid"/>
           </a:ln>
         </p:spPr>
+        <p:txBody>
+          <a:bodyPr/>
+          <a:lstStyle/>
+          <a:p>
+            <a:endParaRPr lang="en-US"/>
+          </a:p>
+        </p:txBody>
       </p:sp>
       <p:sp>
         <p:nvSpPr>
@@ -2570,11 +2654,11 @@
           <a:bodyPr wrap="square" lIns="0" tIns="0" rIns="0" bIns="0" rtlCol="0" anchor="ctr"/>
           <a:lstStyle/>
           <a:p>
-            <a:pPr indent="0" marL="0">
-              <a:buNone/>
-            </a:pPr>
-            <a:r>
-              <a:rPr lang="en-US" sz="1300" b="1" spc="300" kern="0" dirty="0">
+            <a:pPr marL="0" indent="0">
+              <a:buNone/>
+            </a:pPr>
+            <a:r>
+              <a:rPr lang="en-US" sz="1300" b="1" kern="0" spc="300" dirty="0">
                 <a:solidFill>
                   <a:srgbClr val="8E98AE"/>
                 </a:solidFill>
@@ -2609,7 +2693,7 @@
           <a:bodyPr wrap="square" lIns="0" tIns="0" rIns="0" bIns="0" rtlCol="0" anchor="ctr"/>
           <a:lstStyle/>
           <a:p>
-            <a:pPr indent="0" marL="0">
+            <a:pPr marL="0" indent="0">
               <a:lnSpc>
                 <a:spcPct val="106000"/>
               </a:lnSpc>
@@ -2629,7 +2713,7 @@
             <a:endParaRPr lang="en-US" sz="4000" dirty="0"/>
           </a:p>
           <a:p>
-            <a:pPr indent="0" marL="0">
+            <a:pPr marL="0" indent="0">
               <a:lnSpc>
                 <a:spcPct val="106000"/>
               </a:lnSpc>
@@ -2671,7 +2755,7 @@
           <a:bodyPr wrap="square" lIns="0" tIns="0" rIns="0" bIns="0" rtlCol="0" anchor="ctr"/>
           <a:lstStyle/>
           <a:p>
-            <a:pPr indent="0" marL="0">
+            <a:pPr marL="0" indent="0">
               <a:lnSpc>
                 <a:spcPct val="140000"/>
               </a:lnSpc>
@@ -2713,7 +2797,7 @@
           <a:bodyPr wrap="square" lIns="0" tIns="0" rIns="0" bIns="0" rtlCol="0" anchor="ctr"/>
           <a:lstStyle/>
           <a:p>
-            <a:pPr indent="0" marL="0">
+            <a:pPr marL="0" indent="0">
               <a:lnSpc>
                 <a:spcPct val="130000"/>
               </a:lnSpc>
@@ -2733,7 +2817,7 @@
             <a:endParaRPr lang="en-US" sz="2400" dirty="0"/>
           </a:p>
           <a:p>
-            <a:pPr indent="0" marL="0">
+            <a:pPr marL="0" indent="0">
               <a:lnSpc>
                 <a:spcPct val="130000"/>
               </a:lnSpc>
@@ -2753,7 +2837,7 @@
             <a:endParaRPr lang="en-US" sz="2400" dirty="0"/>
           </a:p>
           <a:p>
-            <a:pPr indent="0" marL="0">
+            <a:pPr marL="0" indent="0">
               <a:lnSpc>
                 <a:spcPct val="130000"/>
               </a:lnSpc>
@@ -2795,7 +2879,7 @@
           <a:bodyPr wrap="square" lIns="0" tIns="0" rIns="0" bIns="0" rtlCol="0" anchor="ctr"/>
           <a:lstStyle/>
           <a:p>
-            <a:pPr indent="0" marL="0">
+            <a:pPr marL="0" indent="0">
               <a:buNone/>
             </a:pPr>
             <a:r>
@@ -2834,7 +2918,7 @@
           <a:bodyPr wrap="square" lIns="0" tIns="0" rIns="0" bIns="0" rtlCol="0" anchor="ctr"/>
           <a:lstStyle/>
           <a:p>
-            <a:pPr indent="0" marL="0">
+            <a:pPr marL="0" indent="0">
               <a:buNone/>
             </a:pPr>
             <a:r>
@@ -2873,7 +2957,7 @@
           <a:bodyPr wrap="square" lIns="0" tIns="0" rIns="0" bIns="0" rtlCol="0" anchor="ctr"/>
           <a:lstStyle/>
           <a:p>
-            <a:pPr indent="0" marL="0">
+            <a:pPr marL="0" indent="0">
               <a:buNone/>
             </a:pPr>
             <a:r>
@@ -2913,6 +2997,13 @@
             <a:prstDash val="solid"/>
           </a:ln>
         </p:spPr>
+        <p:txBody>
+          <a:bodyPr/>
+          <a:lstStyle/>
+          <a:p>
+            <a:endParaRPr lang="en-US"/>
+          </a:p>
+        </p:txBody>
       </p:sp>
       <p:sp>
         <p:nvSpPr>
@@ -2935,7 +3026,7 @@
           <a:bodyPr wrap="square" lIns="0" tIns="0" rIns="0" bIns="0" rtlCol="0" anchor="ctr"/>
           <a:lstStyle/>
           <a:p>
-            <a:pPr indent="0" marL="0">
+            <a:pPr marL="0" indent="0">
               <a:buNone/>
             </a:pPr>
             <a:r>
@@ -2974,7 +3065,7 @@
           <a:bodyPr wrap="square" lIns="0" tIns="0" rIns="0" bIns="0" rtlCol="0" anchor="ctr"/>
           <a:lstStyle/>
           <a:p>
-            <a:pPr indent="0" marL="0">
+            <a:pPr marL="0" indent="0">
               <a:buNone/>
             </a:pPr>
             <a:r>
@@ -3013,7 +3104,7 @@
           <a:bodyPr wrap="square" lIns="0" tIns="0" rIns="0" bIns="0" rtlCol="0" anchor="ctr"/>
           <a:lstStyle/>
           <a:p>
-            <a:pPr indent="0" marL="0">
+            <a:pPr marL="0" indent="0">
               <a:buNone/>
             </a:pPr>
             <a:r>
@@ -3053,6 +3144,13 @@
             <a:prstDash val="solid"/>
           </a:ln>
         </p:spPr>
+        <p:txBody>
+          <a:bodyPr/>
+          <a:lstStyle/>
+          <a:p>
+            <a:endParaRPr lang="en-US"/>
+          </a:p>
+        </p:txBody>
       </p:sp>
       <p:sp>
         <p:nvSpPr>
@@ -3075,7 +3173,7 @@
           <a:bodyPr wrap="square" lIns="0" tIns="0" rIns="0" bIns="0" rtlCol="0" anchor="ctr"/>
           <a:lstStyle/>
           <a:p>
-            <a:pPr indent="0" marL="0">
+            <a:pPr marL="0" indent="0">
               <a:buNone/>
             </a:pPr>
             <a:r>
@@ -3114,7 +3212,7 @@
           <a:bodyPr wrap="square" lIns="0" tIns="0" rIns="0" bIns="0" rtlCol="0" anchor="ctr"/>
           <a:lstStyle/>
           <a:p>
-            <a:pPr indent="0" marL="0">
+            <a:pPr marL="0" indent="0">
               <a:buNone/>
             </a:pPr>
             <a:r>
@@ -3153,7 +3251,7 @@
           <a:bodyPr wrap="square" lIns="0" tIns="0" rIns="0" bIns="0" rtlCol="0" anchor="ctr"/>
           <a:lstStyle/>
           <a:p>
-            <a:pPr indent="0" marL="0">
+            <a:pPr marL="0" indent="0">
               <a:buNone/>
             </a:pPr>
             <a:r>
@@ -3193,6 +3291,13 @@
             <a:prstDash val="solid"/>
           </a:ln>
         </p:spPr>
+        <p:txBody>
+          <a:bodyPr/>
+          <a:lstStyle/>
+          <a:p>
+            <a:endParaRPr lang="en-US"/>
+          </a:p>
+        </p:txBody>
       </p:sp>
       <p:sp>
         <p:nvSpPr>
@@ -3215,7 +3320,7 @@
           <a:bodyPr wrap="square" lIns="0" tIns="0" rIns="0" bIns="0" rtlCol="0" anchor="ctr"/>
           <a:lstStyle/>
           <a:p>
-            <a:pPr indent="0" marL="0">
+            <a:pPr marL="0" indent="0">
               <a:buNone/>
             </a:pPr>
             <a:r>
@@ -3254,7 +3359,7 @@
           <a:bodyPr wrap="square" lIns="0" tIns="0" rIns="0" bIns="0" rtlCol="0" anchor="ctr"/>
           <a:lstStyle/>
           <a:p>
-            <a:pPr indent="0" marL="0">
+            <a:pPr marL="0" indent="0">
               <a:buNone/>
             </a:pPr>
             <a:r>
@@ -3293,7 +3398,7 @@
           <a:bodyPr wrap="square" lIns="0" tIns="0" rIns="0" bIns="0" rtlCol="0" anchor="ctr"/>
           <a:lstStyle/>
           <a:p>
-            <a:pPr indent="0" marL="0">
+            <a:pPr marL="0" indent="0">
               <a:buNone/>
             </a:pPr>
             <a:r>
@@ -3333,6 +3438,13 @@
             <a:prstDash val="solid"/>
           </a:ln>
         </p:spPr>
+        <p:txBody>
+          <a:bodyPr/>
+          <a:lstStyle/>
+          <a:p>
+            <a:endParaRPr lang="en-US"/>
+          </a:p>
+        </p:txBody>
       </p:sp>
       <p:sp>
         <p:nvSpPr>
@@ -3355,7 +3467,7 @@
           <a:bodyPr wrap="square" lIns="0" tIns="0" rIns="0" bIns="0" rtlCol="0" anchor="ctr"/>
           <a:lstStyle/>
           <a:p>
-            <a:pPr indent="0" marL="0">
+            <a:pPr marL="0" indent="0">
               <a:buNone/>
             </a:pPr>
             <a:r>
@@ -3394,7 +3506,7 @@
           <a:bodyPr wrap="square" lIns="0" tIns="0" rIns="0" bIns="0" rtlCol="0" anchor="ctr"/>
           <a:lstStyle/>
           <a:p>
-            <a:pPr indent="0" marL="0">
+            <a:pPr marL="0" indent="0">
               <a:buNone/>
             </a:pPr>
             <a:r>
@@ -3433,7 +3545,7 @@
           <a:bodyPr wrap="square" lIns="0" tIns="0" rIns="0" bIns="0" rtlCol="0" anchor="ctr"/>
           <a:lstStyle/>
           <a:p>
-            <a:pPr indent="0" marL="0">
+            <a:pPr marL="0" indent="0">
               <a:buNone/>
             </a:pPr>
             <a:r>
@@ -3473,6 +3585,13 @@
             <a:prstDash val="solid"/>
           </a:ln>
         </p:spPr>
+        <p:txBody>
+          <a:bodyPr/>
+          <a:lstStyle/>
+          <a:p>
+            <a:endParaRPr lang="en-US"/>
+          </a:p>
+        </p:txBody>
       </p:sp>
       <p:sp>
         <p:nvSpPr>
@@ -3495,7 +3614,7 @@
           <a:bodyPr wrap="square" lIns="0" tIns="0" rIns="0" bIns="0" rtlCol="0" anchor="ctr"/>
           <a:lstStyle/>
           <a:p>
-            <a:pPr indent="0" marL="0">
+            <a:pPr marL="0" indent="0">
               <a:buNone/>
             </a:pPr>
             <a:r>
@@ -3534,7 +3653,7 @@
           <a:bodyPr wrap="square" lIns="0" tIns="0" rIns="0" bIns="0" rtlCol="0" anchor="ctr"/>
           <a:lstStyle/>
           <a:p>
-            <a:pPr indent="0" marL="0">
+            <a:pPr marL="0" indent="0">
               <a:buNone/>
             </a:pPr>
             <a:r>
@@ -3573,7 +3692,7 @@
           <a:bodyPr wrap="square" lIns="0" tIns="0" rIns="0" bIns="0" rtlCol="0" anchor="ctr"/>
           <a:lstStyle/>
           <a:p>
-            <a:pPr indent="0" marL="0">
+            <a:pPr marL="0" indent="0">
               <a:buNone/>
             </a:pPr>
             <a:r>
@@ -3613,6 +3732,13 @@
             <a:prstDash val="solid"/>
           </a:ln>
         </p:spPr>
+        <p:txBody>
+          <a:bodyPr/>
+          <a:lstStyle/>
+          <a:p>
+            <a:endParaRPr lang="en-US"/>
+          </a:p>
+        </p:txBody>
       </p:sp>
       <p:sp>
         <p:nvSpPr>
@@ -3635,11 +3761,11 @@
           <a:bodyPr wrap="square" lIns="0" tIns="0" rIns="0" bIns="0" rtlCol="0" anchor="ctr"/>
           <a:lstStyle/>
           <a:p>
-            <a:pPr indent="0" marL="0">
-              <a:buNone/>
-            </a:pPr>
-            <a:r>
-              <a:rPr lang="en-US" sz="1400" b="1" spc="200" kern="0" dirty="0">
+            <a:pPr marL="0" indent="0">
+              <a:buNone/>
+            </a:pPr>
+            <a:r>
+              <a:rPr lang="en-US" sz="1400" b="1" kern="0" spc="200" dirty="0">
                 <a:solidFill>
                   <a:srgbClr val="8E98AE"/>
                 </a:solidFill>
@@ -3649,9 +3775,6 @@
               </a:rPr>
               <a:t>IN THE APP   </a:t>
             </a:r>
-            <a:pPr indent="0" marL="0">
-              <a:buNone/>
-            </a:pPr>
             <a:r>
               <a:rPr lang="en-US" sz="1400" dirty="0">
                 <a:solidFill>
@@ -3688,11 +3811,11 @@
           <a:bodyPr wrap="square" lIns="0" tIns="0" rIns="0" bIns="0" rtlCol="0" anchor="ctr"/>
           <a:lstStyle/>
           <a:p>
-            <a:pPr indent="0" marL="0">
-              <a:buNone/>
-            </a:pPr>
-            <a:r>
-              <a:rPr lang="en-US" sz="1400" b="1" spc="200" kern="0" dirty="0">
+            <a:pPr marL="0" indent="0">
+              <a:buNone/>
+            </a:pPr>
+            <a:r>
+              <a:rPr lang="en-US" sz="1400" b="1" kern="0" spc="200" dirty="0">
                 <a:solidFill>
                   <a:srgbClr val="8E98AE"/>
                 </a:solidFill>
@@ -3702,9 +3825,6 @@
               </a:rPr>
               <a:t>NUMBERS FROM   </a:t>
             </a:r>
-            <a:pPr indent="0" marL="0">
-              <a:buNone/>
-            </a:pPr>
             <a:r>
               <a:rPr lang="en-US" sz="1400" dirty="0">
                 <a:solidFill>
@@ -3766,11 +3886,11 @@
           <a:bodyPr wrap="square" lIns="0" tIns="0" rIns="0" bIns="0" rtlCol="0" anchor="ctr"/>
           <a:lstStyle/>
           <a:p>
-            <a:pPr indent="0" marL="0">
-              <a:buNone/>
-            </a:pPr>
-            <a:r>
-              <a:rPr lang="en-US" sz="1300" b="1" spc="300" kern="0" dirty="0">
+            <a:pPr marL="0" indent="0">
+              <a:buNone/>
+            </a:pPr>
+            <a:r>
+              <a:rPr lang="en-US" sz="1300" b="1" kern="0" spc="300" dirty="0">
                 <a:solidFill>
                   <a:srgbClr val="6E7788"/>
                 </a:solidFill>
@@ -3805,7 +3925,7 @@
           <a:bodyPr wrap="square" lIns="0" tIns="0" rIns="0" bIns="0" rtlCol="0" anchor="ctr"/>
           <a:lstStyle/>
           <a:p>
-            <a:pPr indent="0" marL="0">
+            <a:pPr marL="0" indent="0">
               <a:lnSpc>
                 <a:spcPct val="106000"/>
               </a:lnSpc>
@@ -3825,7 +3945,7 @@
             <a:endParaRPr lang="en-US" sz="4000" dirty="0"/>
           </a:p>
           <a:p>
-            <a:pPr indent="0" marL="0">
+            <a:pPr marL="0" indent="0">
               <a:lnSpc>
                 <a:spcPct val="106000"/>
               </a:lnSpc>
@@ -3870,6 +3990,13 @@
             <a:prstDash val="solid"/>
           </a:ln>
         </p:spPr>
+        <p:txBody>
+          <a:bodyPr/>
+          <a:lstStyle/>
+          <a:p>
+            <a:endParaRPr lang="en-US"/>
+          </a:p>
+        </p:txBody>
       </p:sp>
       <p:sp>
         <p:nvSpPr>
@@ -3892,7 +4019,7 @@
           <a:bodyPr wrap="square" lIns="0" tIns="0" rIns="0" bIns="0" rtlCol="0" anchor="ctr"/>
           <a:lstStyle/>
           <a:p>
-            <a:pPr indent="0" marL="0">
+            <a:pPr marL="0" indent="0">
               <a:buNone/>
             </a:pPr>
             <a:r>
@@ -3931,7 +4058,7 @@
           <a:bodyPr wrap="square" lIns="0" tIns="0" rIns="0" bIns="0" rtlCol="0" anchor="ctr"/>
           <a:lstStyle/>
           <a:p>
-            <a:pPr indent="0" marL="0">
+            <a:pPr marL="0" indent="0">
               <a:buNone/>
             </a:pPr>
             <a:r>
@@ -3973,6 +4100,13 @@
             <a:prstDash val="solid"/>
           </a:ln>
         </p:spPr>
+        <p:txBody>
+          <a:bodyPr/>
+          <a:lstStyle/>
+          <a:p>
+            <a:endParaRPr lang="en-US"/>
+          </a:p>
+        </p:txBody>
       </p:sp>
       <p:sp>
         <p:nvSpPr>
@@ -3995,7 +4129,7 @@
           <a:bodyPr wrap="square" lIns="0" tIns="0" rIns="0" bIns="0" rtlCol="0" anchor="ctr"/>
           <a:lstStyle/>
           <a:p>
-            <a:pPr indent="0" marL="0">
+            <a:pPr marL="0" indent="0">
               <a:buNone/>
             </a:pPr>
             <a:r>
@@ -4034,7 +4168,7 @@
           <a:bodyPr wrap="square" lIns="0" tIns="0" rIns="0" bIns="0" rtlCol="0" anchor="ctr"/>
           <a:lstStyle/>
           <a:p>
-            <a:pPr indent="0" marL="0">
+            <a:pPr marL="0" indent="0">
               <a:buNone/>
             </a:pPr>
             <a:r>
@@ -4076,6 +4210,13 @@
             <a:prstDash val="solid"/>
           </a:ln>
         </p:spPr>
+        <p:txBody>
+          <a:bodyPr/>
+          <a:lstStyle/>
+          <a:p>
+            <a:endParaRPr lang="en-US"/>
+          </a:p>
+        </p:txBody>
       </p:sp>
       <p:sp>
         <p:nvSpPr>
@@ -4098,7 +4239,7 @@
           <a:bodyPr wrap="square" lIns="0" tIns="0" rIns="0" bIns="0" rtlCol="0" anchor="ctr"/>
           <a:lstStyle/>
           <a:p>
-            <a:pPr indent="0" marL="0">
+            <a:pPr marL="0" indent="0">
               <a:buNone/>
             </a:pPr>
             <a:r>
@@ -4137,7 +4278,7 @@
           <a:bodyPr wrap="square" lIns="0" tIns="0" rIns="0" bIns="0" rtlCol="0" anchor="ctr"/>
           <a:lstStyle/>
           <a:p>
-            <a:pPr indent="0" marL="0">
+            <a:pPr marL="0" indent="0">
               <a:buNone/>
             </a:pPr>
             <a:r>
@@ -4176,7 +4317,7 @@
           <a:bodyPr wrap="square" lIns="0" tIns="0" rIns="0" bIns="0" rtlCol="0" anchor="ctr"/>
           <a:lstStyle/>
           <a:p>
-            <a:pPr indent="0" marL="0">
+            <a:pPr marL="0" indent="0">
               <a:buNone/>
             </a:pPr>
             <a:r>
@@ -4215,7 +4356,7 @@
           <a:bodyPr wrap="square" lIns="0" tIns="0" rIns="0" bIns="0" rtlCol="0" anchor="ctr"/>
           <a:lstStyle/>
           <a:p>
-            <a:pPr indent="0" marL="0">
+            <a:pPr marL="0" indent="0">
               <a:buNone/>
             </a:pPr>
             <a:r>
@@ -4254,7 +4395,7 @@
           <a:bodyPr wrap="square" lIns="0" tIns="0" rIns="0" bIns="0" rtlCol="0" anchor="ctr"/>
           <a:lstStyle/>
           <a:p>
-            <a:pPr indent="0" marL="0">
+            <a:pPr marL="0" indent="0">
               <a:buNone/>
             </a:pPr>
             <a:r>
@@ -4294,6 +4435,13 @@
             <a:prstDash val="solid"/>
           </a:ln>
         </p:spPr>
+        <p:txBody>
+          <a:bodyPr/>
+          <a:lstStyle/>
+          <a:p>
+            <a:endParaRPr lang="en-US"/>
+          </a:p>
+        </p:txBody>
       </p:sp>
       <p:sp>
         <p:nvSpPr>
@@ -4316,7 +4464,7 @@
           <a:bodyPr wrap="square" lIns="0" tIns="0" rIns="0" bIns="0" rtlCol="0" anchor="ctr"/>
           <a:lstStyle/>
           <a:p>
-            <a:pPr indent="0" marL="0">
+            <a:pPr marL="0" indent="0">
               <a:buNone/>
             </a:pPr>
             <a:r>
@@ -4355,7 +4503,7 @@
           <a:bodyPr wrap="square" lIns="0" tIns="0" rIns="0" bIns="0" rtlCol="0" anchor="ctr"/>
           <a:lstStyle/>
           <a:p>
-            <a:pPr indent="0" marL="0">
+            <a:pPr marL="0" indent="0">
               <a:buNone/>
             </a:pPr>
             <a:r>
@@ -4394,7 +4542,7 @@
           <a:bodyPr wrap="square" lIns="0" tIns="0" rIns="0" bIns="0" rtlCol="0" anchor="ctr"/>
           <a:lstStyle/>
           <a:p>
-            <a:pPr indent="0" marL="0">
+            <a:pPr marL="0" indent="0">
               <a:buNone/>
             </a:pPr>
             <a:r>
@@ -4434,6 +4582,13 @@
             <a:prstDash val="solid"/>
           </a:ln>
         </p:spPr>
+        <p:txBody>
+          <a:bodyPr/>
+          <a:lstStyle/>
+          <a:p>
+            <a:endParaRPr lang="en-US"/>
+          </a:p>
+        </p:txBody>
       </p:sp>
       <p:sp>
         <p:nvSpPr>
@@ -4456,7 +4611,7 @@
           <a:bodyPr wrap="square" lIns="0" tIns="0" rIns="0" bIns="0" rtlCol="0" anchor="ctr"/>
           <a:lstStyle/>
           <a:p>
-            <a:pPr indent="0" marL="0">
+            <a:pPr marL="0" indent="0">
               <a:buNone/>
             </a:pPr>
             <a:r>
@@ -4495,7 +4650,7 @@
           <a:bodyPr wrap="square" lIns="0" tIns="0" rIns="0" bIns="0" rtlCol="0" anchor="ctr"/>
           <a:lstStyle/>
           <a:p>
-            <a:pPr indent="0" marL="0">
+            <a:pPr marL="0" indent="0">
               <a:buNone/>
             </a:pPr>
             <a:r>
@@ -4534,7 +4689,7 @@
           <a:bodyPr wrap="square" lIns="0" tIns="0" rIns="0" bIns="0" rtlCol="0" anchor="ctr"/>
           <a:lstStyle/>
           <a:p>
-            <a:pPr indent="0" marL="0">
+            <a:pPr marL="0" indent="0">
               <a:buNone/>
             </a:pPr>
             <a:r>
@@ -4574,6 +4729,13 @@
             <a:prstDash val="solid"/>
           </a:ln>
         </p:spPr>
+        <p:txBody>
+          <a:bodyPr/>
+          <a:lstStyle/>
+          <a:p>
+            <a:endParaRPr lang="en-US"/>
+          </a:p>
+        </p:txBody>
       </p:sp>
       <p:sp>
         <p:nvSpPr>
@@ -4596,7 +4758,7 @@
           <a:bodyPr wrap="square" lIns="0" tIns="0" rIns="0" bIns="0" rtlCol="0" anchor="ctr"/>
           <a:lstStyle/>
           <a:p>
-            <a:pPr indent="0" marL="0">
+            <a:pPr marL="0" indent="0">
               <a:buNone/>
             </a:pPr>
             <a:r>
@@ -4635,7 +4797,7 @@
           <a:bodyPr wrap="square" lIns="0" tIns="0" rIns="0" bIns="0" rtlCol="0" anchor="ctr"/>
           <a:lstStyle/>
           <a:p>
-            <a:pPr indent="0" marL="0">
+            <a:pPr marL="0" indent="0">
               <a:buNone/>
             </a:pPr>
             <a:r>
@@ -4674,7 +4836,7 @@
           <a:bodyPr wrap="square" lIns="0" tIns="0" rIns="0" bIns="0" rtlCol="0" anchor="ctr"/>
           <a:lstStyle/>
           <a:p>
-            <a:pPr indent="0" marL="0">
+            <a:pPr marL="0" indent="0">
               <a:buNone/>
             </a:pPr>
             <a:r>
@@ -4714,6 +4876,13 @@
             <a:prstDash val="solid"/>
           </a:ln>
         </p:spPr>
+        <p:txBody>
+          <a:bodyPr/>
+          <a:lstStyle/>
+          <a:p>
+            <a:endParaRPr lang="en-US"/>
+          </a:p>
+        </p:txBody>
       </p:sp>
       <p:sp>
         <p:nvSpPr>
@@ -4736,11 +4905,11 @@
           <a:bodyPr wrap="square" lIns="0" tIns="0" rIns="0" bIns="0" rtlCol="0" anchor="ctr"/>
           <a:lstStyle/>
           <a:p>
-            <a:pPr indent="0" marL="0">
-              <a:buNone/>
-            </a:pPr>
-            <a:r>
-              <a:rPr lang="en-US" sz="1400" b="1" spc="200" kern="0" dirty="0">
+            <a:pPr marL="0" indent="0">
+              <a:buNone/>
+            </a:pPr>
+            <a:r>
+              <a:rPr lang="en-US" sz="1400" b="1" kern="0" spc="200" dirty="0">
                 <a:solidFill>
                   <a:srgbClr val="6E7788"/>
                 </a:solidFill>
@@ -4750,9 +4919,6 @@
               </a:rPr>
               <a:t>IN THE APP   </a:t>
             </a:r>
-            <a:pPr indent="0" marL="0">
-              <a:buNone/>
-            </a:pPr>
             <a:r>
               <a:rPr lang="en-US" sz="1400" dirty="0">
                 <a:solidFill>
@@ -4789,11 +4955,11 @@
           <a:bodyPr wrap="square" lIns="0" tIns="0" rIns="0" bIns="0" rtlCol="0" anchor="ctr"/>
           <a:lstStyle/>
           <a:p>
-            <a:pPr indent="0" marL="0">
-              <a:buNone/>
-            </a:pPr>
-            <a:r>
-              <a:rPr lang="en-US" sz="1400" b="1" spc="200" kern="0" dirty="0">
+            <a:pPr marL="0" indent="0">
+              <a:buNone/>
+            </a:pPr>
+            <a:r>
+              <a:rPr lang="en-US" sz="1400" b="1" kern="0" spc="200" dirty="0">
                 <a:solidFill>
                   <a:srgbClr val="6E7788"/>
                 </a:solidFill>
@@ -4803,9 +4969,6 @@
               </a:rPr>
               <a:t>NUMBERS FROM   </a:t>
             </a:r>
-            <a:pPr indent="0" marL="0">
-              <a:buNone/>
-            </a:pPr>
             <a:r>
               <a:rPr lang="en-US" sz="1400" dirty="0">
                 <a:solidFill>
@@ -4870,6 +5033,13 @@
             <a:prstDash val="solid"/>
           </a:ln>
         </p:spPr>
+        <p:txBody>
+          <a:bodyPr/>
+          <a:lstStyle/>
+          <a:p>
+            <a:endParaRPr lang="en-US"/>
+          </a:p>
+        </p:txBody>
       </p:sp>
       <p:sp>
         <p:nvSpPr>
@@ -4879,8 +5049,8 @@
         </p:nvSpPr>
         <p:spPr>
           <a:xfrm>
-            <a:off x="10058400" y="-365760"/>
-            <a:ext cx="8778240" cy="10972800"/>
+            <a:off x="10058400" y="0"/>
+            <a:ext cx="8229600" cy="10286999"/>
           </a:xfrm>
           <a:prstGeom prst="rect">
             <a:avLst/>
@@ -4895,6 +5065,13 @@
             <a:prstDash val="solid"/>
           </a:ln>
         </p:spPr>
+        <p:txBody>
+          <a:bodyPr/>
+          <a:lstStyle/>
+          <a:p>
+            <a:endParaRPr lang="en-US"/>
+          </a:p>
+        </p:txBody>
       </p:sp>
       <p:sp>
         <p:nvSpPr>
@@ -4917,11 +5094,11 @@
           <a:bodyPr wrap="square" lIns="0" tIns="0" rIns="0" bIns="0" rtlCol="0" anchor="ctr"/>
           <a:lstStyle/>
           <a:p>
-            <a:pPr indent="0" marL="0">
-              <a:buNone/>
-            </a:pPr>
-            <a:r>
-              <a:rPr lang="en-US" sz="1300" b="1" spc="300" kern="0" dirty="0">
+            <a:pPr marL="0" indent="0">
+              <a:buNone/>
+            </a:pPr>
+            <a:r>
+              <a:rPr lang="en-US" sz="1300" b="1" kern="0" spc="300" dirty="0">
                 <a:solidFill>
                   <a:srgbClr val="6E7788"/>
                 </a:solidFill>
@@ -4956,7 +5133,7 @@
           <a:bodyPr wrap="square" lIns="0" tIns="0" rIns="0" bIns="0" rtlCol="0" anchor="ctr"/>
           <a:lstStyle/>
           <a:p>
-            <a:pPr indent="0" marL="0">
+            <a:pPr marL="0" indent="0">
               <a:lnSpc>
                 <a:spcPct val="106000"/>
               </a:lnSpc>
@@ -4976,7 +5153,7 @@
             <a:endParaRPr lang="en-US" sz="3800" dirty="0"/>
           </a:p>
           <a:p>
-            <a:pPr indent="0" marL="0">
+            <a:pPr marL="0" indent="0">
               <a:lnSpc>
                 <a:spcPct val="106000"/>
               </a:lnSpc>
@@ -5018,7 +5195,7 @@
           <a:bodyPr wrap="square" lIns="0" tIns="0" rIns="0" bIns="0" rtlCol="0" anchor="ctr"/>
           <a:lstStyle/>
           <a:p>
-            <a:pPr indent="0" marL="0">
+            <a:pPr marL="0" indent="0">
               <a:lnSpc>
                 <a:spcPct val="140000"/>
               </a:lnSpc>
@@ -5060,11 +5237,11 @@
           <a:bodyPr wrap="square" lIns="0" tIns="0" rIns="0" bIns="0" rtlCol="0" anchor="ctr"/>
           <a:lstStyle/>
           <a:p>
-            <a:pPr indent="0" marL="0">
-              <a:buNone/>
-            </a:pPr>
-            <a:r>
-              <a:rPr lang="en-US" sz="1300" b="1" spc="200" kern="0" dirty="0">
+            <a:pPr marL="0" indent="0">
+              <a:buNone/>
+            </a:pPr>
+            <a:r>
+              <a:rPr lang="en-US" sz="1300" b="1" kern="0" spc="200" dirty="0">
                 <a:solidFill>
                   <a:srgbClr val="6E7788"/>
                 </a:solidFill>
@@ -5099,7 +5276,7 @@
           <a:bodyPr wrap="square" lIns="0" tIns="0" rIns="0" bIns="0" rtlCol="0" anchor="ctr"/>
           <a:lstStyle/>
           <a:p>
-            <a:pPr indent="0" marL="0">
+            <a:pPr marL="0" indent="0">
               <a:buNone/>
             </a:pPr>
             <a:r>
@@ -5138,7 +5315,7 @@
           <a:bodyPr wrap="square" lIns="0" tIns="0" rIns="0" bIns="0" rtlCol="0" anchor="ctr"/>
           <a:lstStyle/>
           <a:p>
-            <a:pPr indent="0" marL="0">
+            <a:pPr marL="0" indent="0">
               <a:buNone/>
             </a:pPr>
             <a:r>
@@ -5178,6 +5355,13 @@
             <a:prstDash val="solid"/>
           </a:ln>
         </p:spPr>
+        <p:txBody>
+          <a:bodyPr/>
+          <a:lstStyle/>
+          <a:p>
+            <a:endParaRPr lang="en-US"/>
+          </a:p>
+        </p:txBody>
       </p:sp>
       <p:sp>
         <p:nvSpPr>
@@ -5200,7 +5384,7 @@
           <a:bodyPr wrap="square" lIns="0" tIns="0" rIns="0" bIns="0" rtlCol="0" anchor="ctr"/>
           <a:lstStyle/>
           <a:p>
-            <a:pPr indent="0" marL="0">
+            <a:pPr marL="0" indent="0">
               <a:buNone/>
             </a:pPr>
             <a:r>
@@ -5239,7 +5423,7 @@
           <a:bodyPr wrap="square" lIns="0" tIns="0" rIns="0" bIns="0" rtlCol="0" anchor="ctr"/>
           <a:lstStyle/>
           <a:p>
-            <a:pPr indent="0" marL="0">
+            <a:pPr marL="0" indent="0">
               <a:buNone/>
             </a:pPr>
             <a:r>
@@ -5279,6 +5463,13 @@
             <a:prstDash val="solid"/>
           </a:ln>
         </p:spPr>
+        <p:txBody>
+          <a:bodyPr/>
+          <a:lstStyle/>
+          <a:p>
+            <a:endParaRPr lang="en-US"/>
+          </a:p>
+        </p:txBody>
       </p:sp>
       <p:sp>
         <p:nvSpPr>
@@ -5301,7 +5492,7 @@
           <a:bodyPr wrap="square" lIns="0" tIns="0" rIns="0" bIns="0" rtlCol="0" anchor="ctr"/>
           <a:lstStyle/>
           <a:p>
-            <a:pPr indent="0" marL="0">
+            <a:pPr marL="0" indent="0">
               <a:buNone/>
             </a:pPr>
             <a:r>
@@ -5340,7 +5531,7 @@
           <a:bodyPr wrap="square" lIns="0" tIns="0" rIns="0" bIns="0" rtlCol="0" anchor="ctr"/>
           <a:lstStyle/>
           <a:p>
-            <a:pPr indent="0" marL="0">
+            <a:pPr marL="0" indent="0">
               <a:buNone/>
             </a:pPr>
             <a:r>
@@ -5380,6 +5571,13 @@
             <a:prstDash val="solid"/>
           </a:ln>
         </p:spPr>
+        <p:txBody>
+          <a:bodyPr/>
+          <a:lstStyle/>
+          <a:p>
+            <a:endParaRPr lang="en-US"/>
+          </a:p>
+        </p:txBody>
       </p:sp>
       <p:sp>
         <p:nvSpPr>
@@ -5402,7 +5600,7 @@
           <a:bodyPr wrap="square" lIns="0" tIns="0" rIns="0" bIns="0" rtlCol="0" anchor="ctr"/>
           <a:lstStyle/>
           <a:p>
-            <a:pPr indent="0" marL="0">
+            <a:pPr marL="0" indent="0">
               <a:buNone/>
             </a:pPr>
             <a:r>
@@ -5441,7 +5639,7 @@
           <a:bodyPr wrap="square" lIns="0" tIns="0" rIns="0" bIns="0" rtlCol="0" anchor="ctr"/>
           <a:lstStyle/>
           <a:p>
-            <a:pPr indent="0" marL="0">
+            <a:pPr marL="0" indent="0">
               <a:buNone/>
             </a:pPr>
             <a:r>
@@ -5481,6 +5679,13 @@
             <a:prstDash val="solid"/>
           </a:ln>
         </p:spPr>
+        <p:txBody>
+          <a:bodyPr/>
+          <a:lstStyle/>
+          <a:p>
+            <a:endParaRPr lang="en-US"/>
+          </a:p>
+        </p:txBody>
       </p:sp>
       <p:sp>
         <p:nvSpPr>
@@ -5503,7 +5708,7 @@
           <a:bodyPr wrap="square" lIns="0" tIns="0" rIns="0" bIns="0" rtlCol="0" anchor="ctr"/>
           <a:lstStyle/>
           <a:p>
-            <a:pPr indent="0" marL="0">
+            <a:pPr marL="0" indent="0">
               <a:buNone/>
             </a:pPr>
             <a:r>
@@ -5542,7 +5747,7 @@
           <a:bodyPr wrap="square" lIns="0" tIns="0" rIns="0" bIns="0" rtlCol="0" anchor="ctr"/>
           <a:lstStyle/>
           <a:p>
-            <a:pPr indent="0" marL="0">
+            <a:pPr marL="0" indent="0">
               <a:buNone/>
             </a:pPr>
             <a:r>
@@ -5581,11 +5786,11 @@
           <a:bodyPr wrap="square" lIns="0" tIns="0" rIns="0" bIns="0" rtlCol="0" anchor="ctr"/>
           <a:lstStyle/>
           <a:p>
-            <a:pPr indent="0" marL="0">
-              <a:buNone/>
-            </a:pPr>
-            <a:r>
-              <a:rPr lang="en-US" sz="1300" b="1" spc="300" kern="0" dirty="0">
+            <a:pPr marL="0" indent="0">
+              <a:buNone/>
+            </a:pPr>
+            <a:r>
+              <a:rPr lang="en-US" sz="1300" b="1" kern="0" spc="300" dirty="0">
                 <a:solidFill>
                   <a:srgbClr val="6E7788"/>
                 </a:solidFill>
@@ -5620,7 +5825,7 @@
           <a:bodyPr wrap="square" lIns="0" tIns="0" rIns="0" bIns="0" rtlCol="0" anchor="ctr"/>
           <a:lstStyle/>
           <a:p>
-            <a:pPr indent="0" marL="0">
+            <a:pPr marL="0" indent="0">
               <a:buNone/>
             </a:pPr>
             <a:r>
@@ -5659,7 +5864,7 @@
           <a:bodyPr wrap="square" lIns="0" tIns="0" rIns="0" bIns="0" rtlCol="0" anchor="ctr"/>
           <a:lstStyle/>
           <a:p>
-            <a:pPr indent="0" marL="0">
+            <a:pPr marL="0" indent="0">
               <a:buNone/>
             </a:pPr>
             <a:r>
@@ -5699,6 +5904,13 @@
             <a:prstDash val="solid"/>
           </a:ln>
         </p:spPr>
+        <p:txBody>
+          <a:bodyPr/>
+          <a:lstStyle/>
+          <a:p>
+            <a:endParaRPr lang="en-US"/>
+          </a:p>
+        </p:txBody>
       </p:sp>
       <p:sp>
         <p:nvSpPr>
@@ -5721,7 +5933,7 @@
           <a:bodyPr wrap="square" lIns="0" tIns="0" rIns="0" bIns="0" rtlCol="0" anchor="ctr"/>
           <a:lstStyle/>
           <a:p>
-            <a:pPr indent="0" marL="0">
+            <a:pPr marL="0" indent="0">
               <a:lnSpc>
                 <a:spcPct val="140000"/>
               </a:lnSpc>
@@ -5763,7 +5975,7 @@
           <a:bodyPr wrap="square" lIns="0" tIns="0" rIns="0" bIns="0" rtlCol="0" anchor="ctr"/>
           <a:lstStyle/>
           <a:p>
-            <a:pPr indent="0" marL="0">
+            <a:pPr marL="0" indent="0">
               <a:lnSpc>
                 <a:spcPct val="140000"/>
               </a:lnSpc>
@@ -5806,6 +6018,13 @@
             <a:prstDash val="solid"/>
           </a:ln>
         </p:spPr>
+        <p:txBody>
+          <a:bodyPr/>
+          <a:lstStyle/>
+          <a:p>
+            <a:endParaRPr lang="en-US"/>
+          </a:p>
+        </p:txBody>
       </p:sp>
       <p:sp>
         <p:nvSpPr>
@@ -5828,11 +6047,11 @@
           <a:bodyPr wrap="square" lIns="0" tIns="0" rIns="0" bIns="0" rtlCol="0" anchor="ctr"/>
           <a:lstStyle/>
           <a:p>
-            <a:pPr indent="0" marL="0">
-              <a:buNone/>
-            </a:pPr>
-            <a:r>
-              <a:rPr lang="en-US" sz="1400" b="1" spc="200" kern="0" dirty="0">
+            <a:pPr marL="0" indent="0">
+              <a:buNone/>
+            </a:pPr>
+            <a:r>
+              <a:rPr lang="en-US" sz="1400" b="1" kern="0" spc="200" dirty="0">
                 <a:solidFill>
                   <a:srgbClr val="6E7788"/>
                 </a:solidFill>
@@ -5842,9 +6061,6 @@
               </a:rPr>
               <a:t>IN THE APP   </a:t>
             </a:r>
-            <a:pPr indent="0" marL="0">
-              <a:buNone/>
-            </a:pPr>
             <a:r>
               <a:rPr lang="en-US" sz="1400" dirty="0">
                 <a:solidFill>
@@ -5881,11 +6097,11 @@
           <a:bodyPr wrap="square" lIns="0" tIns="0" rIns="0" bIns="0" rtlCol="0" anchor="ctr"/>
           <a:lstStyle/>
           <a:p>
-            <a:pPr indent="0" marL="0">
-              <a:buNone/>
-            </a:pPr>
-            <a:r>
-              <a:rPr lang="en-US" sz="1400" b="1" spc="200" kern="0" dirty="0">
+            <a:pPr marL="0" indent="0">
+              <a:buNone/>
+            </a:pPr>
+            <a:r>
+              <a:rPr lang="en-US" sz="1400" b="1" kern="0" spc="200" dirty="0">
                 <a:solidFill>
                   <a:srgbClr val="6E7788"/>
                 </a:solidFill>
@@ -5895,9 +6111,6 @@
               </a:rPr>
               <a:t>NUMBERS FROM   </a:t>
             </a:r>
-            <a:pPr indent="0" marL="0">
-              <a:buNone/>
-            </a:pPr>
             <a:r>
               <a:rPr lang="en-US" sz="1400" dirty="0">
                 <a:solidFill>
@@ -5959,11 +6172,11 @@
           <a:bodyPr wrap="square" lIns="0" tIns="0" rIns="0" bIns="0" rtlCol="0" anchor="ctr"/>
           <a:lstStyle/>
           <a:p>
-            <a:pPr indent="0" marL="0">
-              <a:buNone/>
-            </a:pPr>
-            <a:r>
-              <a:rPr lang="en-US" sz="1300" b="1" spc="300" kern="0" dirty="0">
+            <a:pPr marL="0" indent="0">
+              <a:buNone/>
+            </a:pPr>
+            <a:r>
+              <a:rPr lang="en-US" sz="1300" b="1" kern="0" spc="300" dirty="0">
                 <a:solidFill>
                   <a:srgbClr val="6E7788"/>
                 </a:solidFill>
@@ -5998,7 +6211,7 @@
           <a:bodyPr wrap="square" lIns="0" tIns="0" rIns="0" bIns="0" rtlCol="0" anchor="ctr"/>
           <a:lstStyle/>
           <a:p>
-            <a:pPr indent="0" marL="0">
+            <a:pPr marL="0" indent="0">
               <a:lnSpc>
                 <a:spcPct val="106000"/>
               </a:lnSpc>
@@ -6018,7 +6231,7 @@
             <a:endParaRPr lang="en-US" sz="3800" dirty="0"/>
           </a:p>
           <a:p>
-            <a:pPr indent="0" marL="0">
+            <a:pPr marL="0" indent="0">
               <a:lnSpc>
                 <a:spcPct val="106000"/>
               </a:lnSpc>
@@ -6060,7 +6273,7 @@
           <a:bodyPr wrap="square" lIns="0" tIns="0" rIns="0" bIns="0" rtlCol="0" anchor="ctr"/>
           <a:lstStyle/>
           <a:p>
-            <a:pPr indent="0" marL="0">
+            <a:pPr marL="0" indent="0">
               <a:buNone/>
             </a:pPr>
             <a:r>
@@ -6100,6 +6313,13 @@
             <a:prstDash val="solid"/>
           </a:ln>
         </p:spPr>
+        <p:txBody>
+          <a:bodyPr/>
+          <a:lstStyle/>
+          <a:p>
+            <a:endParaRPr lang="en-US"/>
+          </a:p>
+        </p:txBody>
       </p:sp>
       <p:sp>
         <p:nvSpPr>
@@ -6122,7 +6342,7 @@
           <a:bodyPr wrap="square" lIns="0" tIns="0" rIns="0" bIns="0" rtlCol="0" anchor="ctr"/>
           <a:lstStyle/>
           <a:p>
-            <a:pPr indent="0" marL="0">
+            <a:pPr marL="0" indent="0">
               <a:buNone/>
             </a:pPr>
             <a:r>
@@ -6161,7 +6381,7 @@
           <a:bodyPr wrap="square" lIns="0" tIns="0" rIns="0" bIns="0" rtlCol="0" anchor="ctr"/>
           <a:lstStyle/>
           <a:p>
-            <a:pPr indent="0" marL="0">
+            <a:pPr marL="0" indent="0">
               <a:lnSpc>
                 <a:spcPct val="130000"/>
               </a:lnSpc>
@@ -6204,6 +6424,13 @@
             <a:prstDash val="solid"/>
           </a:ln>
         </p:spPr>
+        <p:txBody>
+          <a:bodyPr/>
+          <a:lstStyle/>
+          <a:p>
+            <a:endParaRPr lang="en-US"/>
+          </a:p>
+        </p:txBody>
       </p:sp>
       <p:sp>
         <p:nvSpPr>
@@ -6227,6 +6454,13 @@
             <a:prstDash val="solid"/>
           </a:ln>
         </p:spPr>
+        <p:txBody>
+          <a:bodyPr/>
+          <a:lstStyle/>
+          <a:p>
+            <a:endParaRPr lang="en-US"/>
+          </a:p>
+        </p:txBody>
       </p:sp>
       <p:sp>
         <p:nvSpPr>
@@ -6249,7 +6483,7 @@
           <a:bodyPr wrap="square" lIns="0" tIns="0" rIns="0" bIns="0" rtlCol="0" anchor="ctr"/>
           <a:lstStyle/>
           <a:p>
-            <a:pPr indent="0" marL="0">
+            <a:pPr marL="0" indent="0">
               <a:buNone/>
             </a:pPr>
             <a:r>
@@ -6288,7 +6522,7 @@
           <a:bodyPr wrap="square" lIns="0" tIns="0" rIns="0" bIns="0" rtlCol="0" anchor="ctr"/>
           <a:lstStyle/>
           <a:p>
-            <a:pPr indent="0" marL="0">
+            <a:pPr marL="0" indent="0">
               <a:lnSpc>
                 <a:spcPct val="130000"/>
               </a:lnSpc>
@@ -6331,6 +6565,13 @@
             <a:prstDash val="solid"/>
           </a:ln>
         </p:spPr>
+        <p:txBody>
+          <a:bodyPr/>
+          <a:lstStyle/>
+          <a:p>
+            <a:endParaRPr lang="en-US"/>
+          </a:p>
+        </p:txBody>
       </p:sp>
       <p:sp>
         <p:nvSpPr>
@@ -6353,7 +6594,7 @@
           <a:bodyPr wrap="square" lIns="0" tIns="0" rIns="0" bIns="0" rtlCol="0" anchor="ctr"/>
           <a:lstStyle/>
           <a:p>
-            <a:pPr indent="0" marL="0">
+            <a:pPr marL="0" indent="0">
               <a:buNone/>
             </a:pPr>
             <a:r>
@@ -6392,7 +6633,7 @@
           <a:bodyPr wrap="square" lIns="0" tIns="0" rIns="0" bIns="0" rtlCol="0" anchor="ctr"/>
           <a:lstStyle/>
           <a:p>
-            <a:pPr indent="0" marL="0">
+            <a:pPr marL="0" indent="0">
               <a:lnSpc>
                 <a:spcPct val="130000"/>
               </a:lnSpc>
@@ -6435,6 +6676,13 @@
             <a:prstDash val="solid"/>
           </a:ln>
         </p:spPr>
+        <p:txBody>
+          <a:bodyPr/>
+          <a:lstStyle/>
+          <a:p>
+            <a:endParaRPr lang="en-US"/>
+          </a:p>
+        </p:txBody>
       </p:sp>
       <p:sp>
         <p:nvSpPr>
@@ -6457,7 +6705,7 @@
           <a:bodyPr wrap="square" lIns="0" tIns="0" rIns="0" bIns="0" rtlCol="0" anchor="ctr"/>
           <a:lstStyle/>
           <a:p>
-            <a:pPr indent="0" marL="0">
+            <a:pPr marL="0" indent="0">
               <a:buNone/>
             </a:pPr>
             <a:r>
@@ -6496,7 +6744,7 @@
           <a:bodyPr wrap="square" lIns="0" tIns="0" rIns="0" bIns="0" rtlCol="0" anchor="ctr"/>
           <a:lstStyle/>
           <a:p>
-            <a:pPr indent="0" marL="0">
+            <a:pPr marL="0" indent="0">
               <a:lnSpc>
                 <a:spcPct val="130000"/>
               </a:lnSpc>
@@ -6539,6 +6787,13 @@
             <a:prstDash val="solid"/>
           </a:ln>
         </p:spPr>
+        <p:txBody>
+          <a:bodyPr/>
+          <a:lstStyle/>
+          <a:p>
+            <a:endParaRPr lang="en-US"/>
+          </a:p>
+        </p:txBody>
       </p:sp>
       <p:sp>
         <p:nvSpPr>
@@ -6561,11 +6816,11 @@
           <a:bodyPr wrap="square" lIns="0" tIns="0" rIns="0" bIns="0" rtlCol="0" anchor="ctr"/>
           <a:lstStyle/>
           <a:p>
-            <a:pPr indent="0" marL="0">
-              <a:buNone/>
-            </a:pPr>
-            <a:r>
-              <a:rPr lang="en-US" sz="1400" b="1" spc="200" kern="0" dirty="0">
+            <a:pPr marL="0" indent="0">
+              <a:buNone/>
+            </a:pPr>
+            <a:r>
+              <a:rPr lang="en-US" sz="1400" b="1" kern="0" spc="200" dirty="0">
                 <a:solidFill>
                   <a:srgbClr val="6E7788"/>
                 </a:solidFill>
@@ -6575,9 +6830,6 @@
               </a:rPr>
               <a:t>IN THE APP   </a:t>
             </a:r>
-            <a:pPr indent="0" marL="0">
-              <a:buNone/>
-            </a:pPr>
             <a:r>
               <a:rPr lang="en-US" sz="1400" dirty="0">
                 <a:solidFill>
@@ -6614,11 +6866,11 @@
           <a:bodyPr wrap="square" lIns="0" tIns="0" rIns="0" bIns="0" rtlCol="0" anchor="ctr"/>
           <a:lstStyle/>
           <a:p>
-            <a:pPr indent="0" marL="0">
-              <a:buNone/>
-            </a:pPr>
-            <a:r>
-              <a:rPr lang="en-US" sz="1400" b="1" spc="200" kern="0" dirty="0">
+            <a:pPr marL="0" indent="0">
+              <a:buNone/>
+            </a:pPr>
+            <a:r>
+              <a:rPr lang="en-US" sz="1400" b="1" kern="0" spc="200" dirty="0">
                 <a:solidFill>
                   <a:srgbClr val="6E7788"/>
                 </a:solidFill>
@@ -6628,9 +6880,6 @@
               </a:rPr>
               <a:t>NUMBERS FROM   </a:t>
             </a:r>
-            <a:pPr indent="0" marL="0">
-              <a:buNone/>
-            </a:pPr>
             <a:r>
               <a:rPr lang="en-US" sz="1400" dirty="0">
                 <a:solidFill>
@@ -6647,6 +6896,292 @@
         </p:txBody>
       </p:sp>
     </p:spTree>
+  </p:cSld>
+  <p:clrMapOvr>
+    <a:masterClrMapping/>
+  </p:clrMapOvr>
+</p:sld>
+</file>
+
+<file path=ppt/slides/slide7.xml><?xml version="1.0" encoding="utf-8"?>
+<p:sld xmlns:a="http://schemas.openxmlformats.org/drawingml/2006/main" xmlns:r="http://schemas.openxmlformats.org/officeDocument/2006/relationships" xmlns:p="http://schemas.openxmlformats.org/presentationml/2006/main">
+  <p:cSld>
+    <p:spTree>
+      <p:nvGrpSpPr>
+        <p:cNvPr id="1" name="">
+          <a:extLst>
+            <a:ext uri="{FF2B5EF4-FFF2-40B4-BE49-F238E27FC236}">
+              <a16:creationId xmlns:a16="http://schemas.microsoft.com/office/drawing/2014/main" id="{61160339-09A9-071D-84C8-E7B7FC4AE87B}"/>
+            </a:ext>
+          </a:extLst>
+        </p:cNvPr>
+        <p:cNvGrpSpPr/>
+        <p:nvPr/>
+      </p:nvGrpSpPr>
+      <p:grpSpPr>
+        <a:xfrm>
+          <a:off x="0" y="0"/>
+          <a:ext cx="0" cy="0"/>
+          <a:chOff x="0" y="0"/>
+          <a:chExt cx="0" cy="0"/>
+        </a:xfrm>
+      </p:grpSpPr>
+      <p:sp>
+        <p:nvSpPr>
+          <p:cNvPr id="2" name="Shape 0">
+            <a:extLst>
+              <a:ext uri="{FF2B5EF4-FFF2-40B4-BE49-F238E27FC236}">
+                <a16:creationId xmlns:a16="http://schemas.microsoft.com/office/drawing/2014/main" id="{6C43EB58-73C4-49BB-2165-5FDBF41F33C9}"/>
+              </a:ext>
+            </a:extLst>
+          </p:cNvPr>
+          <p:cNvSpPr/>
+          <p:nvPr/>
+        </p:nvSpPr>
+        <p:spPr>
+          <a:xfrm>
+            <a:off x="0" y="0"/>
+            <a:ext cx="18288000" cy="10287000"/>
+          </a:xfrm>
+          <a:prstGeom prst="rect">
+            <a:avLst/>
+          </a:prstGeom>
+          <a:solidFill>
+            <a:srgbClr val="232E54"/>
+          </a:solidFill>
+          <a:ln w="12700">
+            <a:solidFill>
+              <a:srgbClr val="232E54"/>
+            </a:solidFill>
+            <a:prstDash val="solid"/>
+          </a:ln>
+        </p:spPr>
+        <p:txBody>
+          <a:bodyPr/>
+          <a:lstStyle/>
+          <a:p>
+            <a:endParaRPr lang="en-US"/>
+          </a:p>
+        </p:txBody>
+      </p:sp>
+      <p:sp>
+        <p:nvSpPr>
+          <p:cNvPr id="3" name="Shape 1">
+            <a:extLst>
+              <a:ext uri="{FF2B5EF4-FFF2-40B4-BE49-F238E27FC236}">
+                <a16:creationId xmlns:a16="http://schemas.microsoft.com/office/drawing/2014/main" id="{A5A59A27-37FF-EF7F-1034-410C72E39F0D}"/>
+              </a:ext>
+            </a:extLst>
+          </p:cNvPr>
+          <p:cNvSpPr/>
+          <p:nvPr/>
+        </p:nvSpPr>
+        <p:spPr>
+          <a:xfrm>
+            <a:off x="0" y="9182636"/>
+            <a:ext cx="18288000" cy="1104363"/>
+          </a:xfrm>
+          <a:prstGeom prst="rect">
+            <a:avLst/>
+          </a:prstGeom>
+          <a:solidFill>
+            <a:srgbClr val="324070"/>
+          </a:solidFill>
+          <a:ln w="12700">
+            <a:solidFill>
+              <a:srgbClr val="324070"/>
+            </a:solidFill>
+            <a:prstDash val="solid"/>
+          </a:ln>
+        </p:spPr>
+        <p:txBody>
+          <a:bodyPr/>
+          <a:lstStyle/>
+          <a:p>
+            <a:endParaRPr lang="en-US"/>
+          </a:p>
+        </p:txBody>
+      </p:sp>
+      <p:sp>
+        <p:nvSpPr>
+          <p:cNvPr id="4" name="Text 2">
+            <a:extLst>
+              <a:ext uri="{FF2B5EF4-FFF2-40B4-BE49-F238E27FC236}">
+                <a16:creationId xmlns:a16="http://schemas.microsoft.com/office/drawing/2014/main" id="{97698546-F9C7-F70D-7750-1BC89EEA285A}"/>
+              </a:ext>
+            </a:extLst>
+          </p:cNvPr>
+          <p:cNvSpPr txBox="1"/>
+          <p:nvPr/>
+        </p:nvSpPr>
+        <p:spPr>
+          <a:xfrm>
+            <a:off x="4937760" y="3297314"/>
+            <a:ext cx="8412480" cy="2103120"/>
+          </a:xfrm>
+          <a:prstGeom prst="rect">
+            <a:avLst/>
+          </a:prstGeom>
+          <a:noFill/>
+          <a:ln/>
+        </p:spPr>
+        <p:txBody>
+          <a:bodyPr wrap="square" lIns="0" tIns="0" rIns="0" bIns="0" rtlCol="0" anchor="ctr"/>
+          <a:lstStyle/>
+          <a:p>
+            <a:pPr marL="0" indent="0" algn="ctr">
+              <a:lnSpc>
+                <a:spcPct val="90000"/>
+              </a:lnSpc>
+              <a:buNone/>
+            </a:pPr>
+            <a:r>
+              <a:rPr lang="en-US" sz="11600" dirty="0">
+                <a:solidFill>
+                  <a:srgbClr val="FFFFFF"/>
+                </a:solidFill>
+                <a:latin typeface="Bahnschrift SemiBold" pitchFamily="34" charset="0"/>
+                <a:ea typeface="Bahnschrift SemiBold" pitchFamily="34" charset="-122"/>
+                <a:cs typeface="Bahnschrift SemiBold" pitchFamily="34" charset="-120"/>
+              </a:rPr>
+              <a:t>THANK YOU</a:t>
+            </a:r>
+            <a:endParaRPr lang="en-US" sz="11600" dirty="0"/>
+          </a:p>
+        </p:txBody>
+      </p:sp>
+      <p:sp>
+        <p:nvSpPr>
+          <p:cNvPr id="5" name="Shape 3">
+            <a:extLst>
+              <a:ext uri="{FF2B5EF4-FFF2-40B4-BE49-F238E27FC236}">
+                <a16:creationId xmlns:a16="http://schemas.microsoft.com/office/drawing/2014/main" id="{81F81FF6-8524-41E0-7F88-84371AA2DFAF}"/>
+              </a:ext>
+            </a:extLst>
+          </p:cNvPr>
+          <p:cNvSpPr/>
+          <p:nvPr/>
+        </p:nvSpPr>
+        <p:spPr>
+          <a:xfrm>
+            <a:off x="2446986" y="5356322"/>
+            <a:ext cx="13084935" cy="0"/>
+          </a:xfrm>
+          <a:prstGeom prst="line">
+            <a:avLst/>
+          </a:prstGeom>
+          <a:noFill/>
+          <a:ln w="25400">
+            <a:solidFill>
+              <a:srgbClr val="44528A"/>
+            </a:solidFill>
+            <a:prstDash val="solid"/>
+          </a:ln>
+        </p:spPr>
+        <p:txBody>
+          <a:bodyPr/>
+          <a:lstStyle/>
+          <a:p>
+            <a:endParaRPr lang="en-US"/>
+          </a:p>
+        </p:txBody>
+      </p:sp>
+      <p:sp>
+        <p:nvSpPr>
+          <p:cNvPr id="6" name="Text 4">
+            <a:extLst>
+              <a:ext uri="{FF2B5EF4-FFF2-40B4-BE49-F238E27FC236}">
+                <a16:creationId xmlns:a16="http://schemas.microsoft.com/office/drawing/2014/main" id="{64BCBE2E-6BB5-E28D-A70E-28237DDEA8CD}"/>
+              </a:ext>
+            </a:extLst>
+          </p:cNvPr>
+          <p:cNvSpPr txBox="1"/>
+          <p:nvPr/>
+        </p:nvSpPr>
+        <p:spPr>
+          <a:xfrm>
+            <a:off x="5638370" y="5727556"/>
+            <a:ext cx="7011259" cy="548640"/>
+          </a:xfrm>
+          <a:prstGeom prst="rect">
+            <a:avLst/>
+          </a:prstGeom>
+          <a:noFill/>
+          <a:ln/>
+        </p:spPr>
+        <p:txBody>
+          <a:bodyPr wrap="square" lIns="0" tIns="0" rIns="0" bIns="0" rtlCol="0" anchor="ctr"/>
+          <a:lstStyle/>
+          <a:p>
+            <a:pPr marL="0" indent="0">
+              <a:buNone/>
+            </a:pPr>
+            <a:r>
+              <a:rPr lang="en-US" sz="2000" b="1" kern="0" spc="600" dirty="0">
+                <a:solidFill>
+                  <a:srgbClr val="FFFFFF"/>
+                </a:solidFill>
+                <a:latin typeface="Calibri" pitchFamily="34" charset="0"/>
+                <a:ea typeface="Calibri" pitchFamily="34" charset="-122"/>
+                <a:cs typeface="Calibri" pitchFamily="34" charset="-120"/>
+              </a:rPr>
+              <a:t>I am happy to answer any questions</a:t>
+            </a:r>
+            <a:endParaRPr lang="en-US" sz="2000" dirty="0"/>
+          </a:p>
+        </p:txBody>
+      </p:sp>
+      <p:sp>
+        <p:nvSpPr>
+          <p:cNvPr id="12" name="Text 10">
+            <a:extLst>
+              <a:ext uri="{FF2B5EF4-FFF2-40B4-BE49-F238E27FC236}">
+                <a16:creationId xmlns:a16="http://schemas.microsoft.com/office/drawing/2014/main" id="{E0FD87FF-FAA9-33A1-3962-112A150ABC9A}"/>
+              </a:ext>
+            </a:extLst>
+          </p:cNvPr>
+          <p:cNvSpPr txBox="1"/>
+          <p:nvPr/>
+        </p:nvSpPr>
+        <p:spPr>
+          <a:xfrm>
+            <a:off x="1280160" y="9594117"/>
+            <a:ext cx="5674432" cy="365760"/>
+          </a:xfrm>
+          <a:prstGeom prst="rect">
+            <a:avLst/>
+          </a:prstGeom>
+          <a:noFill/>
+          <a:ln/>
+        </p:spPr>
+        <p:txBody>
+          <a:bodyPr wrap="square" lIns="0" tIns="0" rIns="0" bIns="0" rtlCol="0" anchor="ctr"/>
+          <a:lstStyle/>
+          <a:p>
+            <a:pPr marL="0" indent="0">
+              <a:buNone/>
+            </a:pPr>
+            <a:r>
+              <a:rPr lang="en-US" sz="1300" b="1" kern="0" spc="300" dirty="0">
+                <a:solidFill>
+                  <a:srgbClr val="8E98AE"/>
+                </a:solidFill>
+                <a:latin typeface="Calibri" pitchFamily="34" charset="0"/>
+                <a:ea typeface="Calibri" pitchFamily="34" charset="-122"/>
+                <a:cs typeface="Calibri" pitchFamily="34" charset="-120"/>
+              </a:rPr>
+              <a:t>SOUTHWEST MN HACKS 2026  ·  SCHWAN'S PROMPT 01</a:t>
+            </a:r>
+            <a:endParaRPr lang="en-US" sz="1300" dirty="0"/>
+          </a:p>
+        </p:txBody>
+      </p:sp>
+    </p:spTree>
+    <p:extLst>
+      <p:ext uri="{BB962C8B-B14F-4D97-AF65-F5344CB8AC3E}">
+        <p14:creationId xmlns:p14="http://schemas.microsoft.com/office/powerpoint/2010/main" val="3577902648"/>
+      </p:ext>
+    </p:extLst>
   </p:cSld>
   <p:clrMapOvr>
     <a:masterClrMapping/>
@@ -6947,4 +7482,319 @@
     </a:ext>
   </a:extLst>
 </a:theme>
+</file>
+
+<file path=ppt/theme/theme2.xml><?xml version="1.0" encoding="utf-8"?>
+<a:theme xmlns:a="http://schemas.openxmlformats.org/drawingml/2006/main" name="Office Theme">
+  <a:themeElements>
+    <a:clrScheme name="Office">
+      <a:dk1>
+        <a:sysClr val="windowText" lastClr="000000"/>
+      </a:dk1>
+      <a:lt1>
+        <a:sysClr val="window" lastClr="FFFFFF"/>
+      </a:lt1>
+      <a:dk2>
+        <a:srgbClr val="0E2841"/>
+      </a:dk2>
+      <a:lt2>
+        <a:srgbClr val="E8E8E8"/>
+      </a:lt2>
+      <a:accent1>
+        <a:srgbClr val="156082"/>
+      </a:accent1>
+      <a:accent2>
+        <a:srgbClr val="E97132"/>
+      </a:accent2>
+      <a:accent3>
+        <a:srgbClr val="196B24"/>
+      </a:accent3>
+      <a:accent4>
+        <a:srgbClr val="0F9ED5"/>
+      </a:accent4>
+      <a:accent5>
+        <a:srgbClr val="A02B93"/>
+      </a:accent5>
+      <a:accent6>
+        <a:srgbClr val="4EA72E"/>
+      </a:accent6>
+      <a:hlink>
+        <a:srgbClr val="467886"/>
+      </a:hlink>
+      <a:folHlink>
+        <a:srgbClr val="96607D"/>
+      </a:folHlink>
+    </a:clrScheme>
+    <a:fontScheme name="Office">
+      <a:majorFont>
+        <a:latin typeface="Aptos Display" panose="02110004020202020204"/>
+        <a:ea typeface=""/>
+        <a:cs typeface=""/>
+        <a:font script="Jpan" typeface="游ゴシック Light"/>
+        <a:font script="Hang" typeface="맑은 고딕"/>
+        <a:font script="Hans" typeface="等线 Light"/>
+        <a:font script="Hant" typeface="新細明體"/>
+        <a:font script="Arab" typeface="Times New Roman"/>
+        <a:font script="Hebr" typeface="Times New Roman"/>
+        <a:font script="Thai" typeface="Angsana New"/>
+        <a:font script="Ethi" typeface="Nyala"/>
+        <a:font script="Beng" typeface="Vrinda"/>
+        <a:font script="Gujr" typeface="Shruti"/>
+        <a:font script="Khmr" typeface="MoolBoran"/>
+        <a:font script="Knda" typeface="Tunga"/>
+        <a:font script="Guru" typeface="Raavi"/>
+        <a:font script="Cans" typeface="Euphemia"/>
+        <a:font script="Cher" typeface="Plantagenet Cherokee"/>
+        <a:font script="Yiii" typeface="Microsoft Yi Baiti"/>
+        <a:font script="Tibt" typeface="Microsoft Himalaya"/>
+        <a:font script="Thaa" typeface="MV Boli"/>
+        <a:font script="Deva" typeface="Mangal"/>
+        <a:font script="Telu" typeface="Gautami"/>
+        <a:font script="Taml" typeface="Latha"/>
+        <a:font script="Syrc" typeface="Estrangelo Edessa"/>
+        <a:font script="Orya" typeface="Kalinga"/>
+        <a:font script="Mlym" typeface="Kartika"/>
+        <a:font script="Laoo" typeface="DokChampa"/>
+        <a:font script="Sinh" typeface="Iskoola Pota"/>
+        <a:font script="Mong" typeface="Mongolian Baiti"/>
+        <a:font script="Viet" typeface="Times New Roman"/>
+        <a:font script="Uigh" typeface="Microsoft Uighur"/>
+        <a:font script="Geor" typeface="Sylfaen"/>
+        <a:font script="Armn" typeface="Arial"/>
+        <a:font script="Bugi" typeface="Leelawadee UI"/>
+        <a:font script="Bopo" typeface="Microsoft JhengHei"/>
+        <a:font script="Java" typeface="Javanese Text"/>
+        <a:font script="Lisu" typeface="Segoe UI"/>
+        <a:font script="Mymr" typeface="Myanmar Text"/>
+        <a:font script="Nkoo" typeface="Ebrima"/>
+        <a:font script="Olck" typeface="Nirmala UI"/>
+        <a:font script="Osma" typeface="Ebrima"/>
+        <a:font script="Phag" typeface="Phagspa"/>
+        <a:font script="Syrn" typeface="Estrangelo Edessa"/>
+        <a:font script="Syrj" typeface="Estrangelo Edessa"/>
+        <a:font script="Syre" typeface="Estrangelo Edessa"/>
+        <a:font script="Sora" typeface="Nirmala UI"/>
+        <a:font script="Tale" typeface="Microsoft Tai Le"/>
+        <a:font script="Talu" typeface="Microsoft New Tai Lue"/>
+        <a:font script="Tfng" typeface="Ebrima"/>
+      </a:majorFont>
+      <a:minorFont>
+        <a:latin typeface="Aptos" panose="02110004020202020204"/>
+        <a:ea typeface=""/>
+        <a:cs typeface=""/>
+        <a:font script="Jpan" typeface="游ゴシック"/>
+        <a:font script="Hang" typeface="맑은 고딕"/>
+        <a:font script="Hans" typeface="等线"/>
+        <a:font script="Hant" typeface="新細明體"/>
+        <a:font script="Arab" typeface="Arial"/>
+        <a:font script="Hebr" typeface="Arial"/>
+        <a:font script="Thai" typeface="Cordia New"/>
+        <a:font script="Ethi" typeface="Nyala"/>
+        <a:font script="Beng" typeface="Vrinda"/>
+        <a:font script="Gujr" typeface="Shruti"/>
+        <a:font script="Khmr" typeface="DaunPenh"/>
+        <a:font script="Knda" typeface="Tunga"/>
+        <a:font script="Guru" typeface="Raavi"/>
+        <a:font script="Cans" typeface="Euphemia"/>
+        <a:font script="Cher" typeface="Plantagenet Cherokee"/>
+        <a:font script="Yiii" typeface="Microsoft Yi Baiti"/>
+        <a:font script="Tibt" typeface="Microsoft Himalaya"/>
+        <a:font script="Thaa" typeface="MV Boli"/>
+        <a:font script="Deva" typeface="Mangal"/>
+        <a:font script="Telu" typeface="Gautami"/>
+        <a:font script="Taml" typeface="Latha"/>
+        <a:font script="Syrc" typeface="Estrangelo Edessa"/>
+        <a:font script="Orya" typeface="Kalinga"/>
+        <a:font script="Mlym" typeface="Kartika"/>
+        <a:font script="Laoo" typeface="DokChampa"/>
+        <a:font script="Sinh" typeface="Iskoola Pota"/>
+        <a:font script="Mong" typeface="Mongolian Baiti"/>
+        <a:font script="Viet" typeface="Arial"/>
+        <a:font script="Uigh" typeface="Microsoft Uighur"/>
+        <a:font script="Geor" typeface="Sylfaen"/>
+        <a:font script="Armn" typeface="Arial"/>
+        <a:font script="Bugi" typeface="Leelawadee UI"/>
+        <a:font script="Bopo" typeface="Microsoft JhengHei"/>
+        <a:font script="Java" typeface="Javanese Text"/>
+        <a:font script="Lisu" typeface="Segoe UI"/>
+        <a:font script="Mymr" typeface="Myanmar Text"/>
+        <a:font script="Nkoo" typeface="Ebrima"/>
+        <a:font script="Olck" typeface="Nirmala UI"/>
+        <a:font script="Osma" typeface="Ebrima"/>
+        <a:font script="Phag" typeface="Phagspa"/>
+        <a:font script="Syrn" typeface="Estrangelo Edessa"/>
+        <a:font script="Syrj" typeface="Estrangelo Edessa"/>
+        <a:font script="Syre" typeface="Estrangelo Edessa"/>
+        <a:font script="Sora" typeface="Nirmala UI"/>
+        <a:font script="Tale" typeface="Microsoft Tai Le"/>
+        <a:font script="Talu" typeface="Microsoft New Tai Lue"/>
+        <a:font script="Tfng" typeface="Ebrima"/>
+      </a:minorFont>
+    </a:fontScheme>
+    <a:fmtScheme name="Office">
+      <a:fillStyleLst>
+        <a:solidFill>
+          <a:schemeClr val="phClr"/>
+        </a:solidFill>
+        <a:gradFill rotWithShape="1">
+          <a:gsLst>
+            <a:gs pos="0">
+              <a:schemeClr val="phClr">
+                <a:lumMod val="110000"/>
+                <a:satMod val="105000"/>
+                <a:tint val="67000"/>
+              </a:schemeClr>
+            </a:gs>
+            <a:gs pos="50000">
+              <a:schemeClr val="phClr">
+                <a:lumMod val="105000"/>
+                <a:satMod val="103000"/>
+                <a:tint val="73000"/>
+              </a:schemeClr>
+            </a:gs>
+            <a:gs pos="100000">
+              <a:schemeClr val="phClr">
+                <a:lumMod val="105000"/>
+                <a:satMod val="109000"/>
+                <a:tint val="81000"/>
+              </a:schemeClr>
+            </a:gs>
+          </a:gsLst>
+          <a:lin ang="5400000" scaled="0"/>
+        </a:gradFill>
+        <a:gradFill rotWithShape="1">
+          <a:gsLst>
+            <a:gs pos="0">
+              <a:schemeClr val="phClr">
+                <a:satMod val="103000"/>
+                <a:lumMod val="102000"/>
+                <a:tint val="94000"/>
+              </a:schemeClr>
+            </a:gs>
+            <a:gs pos="50000">
+              <a:schemeClr val="phClr">
+                <a:satMod val="110000"/>
+                <a:lumMod val="100000"/>
+                <a:shade val="100000"/>
+              </a:schemeClr>
+            </a:gs>
+            <a:gs pos="100000">
+              <a:schemeClr val="phClr">
+                <a:lumMod val="99000"/>
+                <a:satMod val="120000"/>
+                <a:shade val="78000"/>
+              </a:schemeClr>
+            </a:gs>
+          </a:gsLst>
+          <a:lin ang="5400000" scaled="0"/>
+        </a:gradFill>
+      </a:fillStyleLst>
+      <a:lnStyleLst>
+        <a:ln w="12700" cap="flat" cmpd="sng" algn="ctr">
+          <a:solidFill>
+            <a:schemeClr val="phClr"/>
+          </a:solidFill>
+          <a:prstDash val="solid"/>
+          <a:miter lim="800000"/>
+        </a:ln>
+        <a:ln w="19050" cap="flat" cmpd="sng" algn="ctr">
+          <a:solidFill>
+            <a:schemeClr val="phClr"/>
+          </a:solidFill>
+          <a:prstDash val="solid"/>
+          <a:miter lim="800000"/>
+        </a:ln>
+        <a:ln w="25400" cap="flat" cmpd="sng" algn="ctr">
+          <a:solidFill>
+            <a:schemeClr val="phClr"/>
+          </a:solidFill>
+          <a:prstDash val="solid"/>
+          <a:miter lim="800000"/>
+        </a:ln>
+      </a:lnStyleLst>
+      <a:effectStyleLst>
+        <a:effectStyle>
+          <a:effectLst/>
+        </a:effectStyle>
+        <a:effectStyle>
+          <a:effectLst/>
+        </a:effectStyle>
+        <a:effectStyle>
+          <a:effectLst>
+            <a:outerShdw blurRad="57150" dist="19050" dir="5400000" algn="ctr" rotWithShape="0">
+              <a:srgbClr val="000000">
+                <a:alpha val="63000"/>
+              </a:srgbClr>
+            </a:outerShdw>
+          </a:effectLst>
+        </a:effectStyle>
+      </a:effectStyleLst>
+      <a:bgFillStyleLst>
+        <a:solidFill>
+          <a:schemeClr val="phClr"/>
+        </a:solidFill>
+        <a:solidFill>
+          <a:schemeClr val="phClr">
+            <a:tint val="95000"/>
+            <a:satMod val="170000"/>
+          </a:schemeClr>
+        </a:solidFill>
+        <a:gradFill rotWithShape="1">
+          <a:gsLst>
+            <a:gs pos="0">
+              <a:schemeClr val="phClr">
+                <a:tint val="93000"/>
+                <a:satMod val="150000"/>
+                <a:shade val="98000"/>
+                <a:lumMod val="102000"/>
+              </a:schemeClr>
+            </a:gs>
+            <a:gs pos="50000">
+              <a:schemeClr val="phClr">
+                <a:tint val="98000"/>
+                <a:satMod val="130000"/>
+                <a:shade val="90000"/>
+                <a:lumMod val="103000"/>
+              </a:schemeClr>
+            </a:gs>
+            <a:gs pos="100000">
+              <a:schemeClr val="phClr">
+                <a:shade val="63000"/>
+                <a:satMod val="120000"/>
+              </a:schemeClr>
+            </a:gs>
+          </a:gsLst>
+          <a:lin ang="5400000" scaled="0"/>
+        </a:gradFill>
+      </a:bgFillStyleLst>
+    </a:fmtScheme>
+  </a:themeElements>
+  <a:objectDefaults>
+    <a:lnDef>
+      <a:spPr/>
+      <a:bodyPr/>
+      <a:lstStyle/>
+      <a:style>
+        <a:lnRef idx="2">
+          <a:schemeClr val="accent1"/>
+        </a:lnRef>
+        <a:fillRef idx="0">
+          <a:schemeClr val="accent1"/>
+        </a:fillRef>
+        <a:effectRef idx="1">
+          <a:schemeClr val="accent1"/>
+        </a:effectRef>
+        <a:fontRef idx="minor">
+          <a:schemeClr val="tx1"/>
+        </a:fontRef>
+      </a:style>
+    </a:lnDef>
+  </a:objectDefaults>
+  <a:extraClrSchemeLst/>
+  <a:extLst>
+    <a:ext uri="{05A4C25C-085E-4340-85A3-A5531E510DB2}">
+      <thm15:themeFamily xmlns:thm15="http://schemas.microsoft.com/office/thememl/2012/main" name="Office Theme" id="{2E142A2C-CD16-42D6-873A-C26D2A0506FA}" vid="{1BDDFF52-6CD6-40A5-AB3C-68EB2F1E4D0A}"/>
+    </a:ext>
+  </a:extLst>
+</a:theme>
 </file>
</xml_diff>

<commit_message>
move prep material out of the repository and tidy the public tree
</commit_message>
<xml_diff>
--- a/exports/SkillSight.pptx
+++ b/exports/SkillSight.pptx
@@ -524,11 +524,19 @@
           <a:lstStyle/>
           <a:p>
             <a:r>
-              <a:rPr lang="en-US" dirty="0"/>
-              <a:t>0:15 to 0:40  THE PROBLEM
-"Schwan's runs more than a dozen US plants across four job groups, and a new plant opens in 2027."
-"But ask a simple question. If the person who knows the ammonia refrigeration system leaves, who else can do it? Today that answer takes phone calls to three plants."
-Point at the zero. That is the whole problem in one number.</a:t>
+              <a:t>0:15 to 0:40  THE PROBLEM</a:t>
+            </a:r>
+          </a:p>
+          <a:p/>
+          <a:p>
+            <a:r>
+              <a:t>"Schwan's runs more than a dozen US plants across four job groups, and a new plant opens in 2027."</a:t>
+            </a:r>
+          </a:p>
+          <a:p/>
+          <a:p>
+            <a:r>
+              <a:t>"But ask a simple question. If the person who knows the ammonia refrigeration system leaves, who else can do it? Today that answer takes phone calls to three plants."</a:t>
             </a:r>
           </a:p>
         </p:txBody>
@@ -614,11 +622,19 @@
           <a:lstStyle/>
           <a:p>
             <a:r>
-              <a:rPr lang="en-US" dirty="0"/>
-              <a:t>0:40 to 1:15  THE FINDING
-"Six skills in this demo are held by three people or fewer. One is held by a single person: frozen dough formulation, at the Marshall R&amp;D centre."
-"Two of these are ammonia refrigeration techs who are close to retirement. That one is not guesswork. Ammonia systems over ten thousand pounds are an OSHA covered process, so the list of trained operators is kept by law. The data already exists."
-Slow down here. This is the slide people remember.</a:t>
+              <a:t>0:40 to 1:15  THE FINDING</a:t>
+            </a:r>
+          </a:p>
+          <a:p/>
+          <a:p>
+            <a:r>
+              <a:t>"Six skills in this demo are held by three people or fewer. One is held by a single person: frozen dough formulation, at the Marshall R&amp;D centre."</a:t>
+            </a:r>
+          </a:p>
+          <a:p/>
+          <a:p>
+            <a:r>
+              <a:t>"Two of these are ammonia refrigeration techs who are close to retirement. That one is not guesswork. Ammonia systems over ten thousand pounds are an OSHA covered process, so the list of trained operators is kept by law. The data already exists."</a:t>
             </a:r>
           </a:p>
         </p:txBody>
@@ -704,12 +720,25 @@
           <a:lstStyle/>
           <a:p>
             <a:r>
-              <a:rPr lang="en-US" dirty="0"/>
-              <a:t>1:15 to 2:00  THE ANSWER  (the core of the pitch)
-"Most dashboards show numbers and stop. This one scores every at-risk skill on three things: how much it hurts, how few people hold it, and how big the gap is. Then it sorts them."
-"So a manager does not get a puzzle. They get an order of work. Fix frozen dough first, and here is the first step: pair the expert with two mentees."
-"Each step is one of the five methods the challenge names. Training, mentoring, certification, job rotation, project experience."
-If you are demoing live, this is where you switch to the app and tick one plan box.</a:t>
+              <a:t>1:15 to 2:00  THE ANSWER  </a:t>
+            </a:r>
+          </a:p>
+          <a:p/>
+          <a:p>
+            <a:r>
+              <a:t>"Most dashboards show numbers and stop. This one scores every at-risk skill on three things: how much it hurts, how few people hold it, and how big the gap is. Then it sorts them."</a:t>
+            </a:r>
+          </a:p>
+          <a:p/>
+          <a:p>
+            <a:r>
+              <a:t>"So a manager does not get a puzzle. They get an order of work. Fix frozen dough first, and here is the first step: pair the expert with two mentees."</a:t>
+            </a:r>
+          </a:p>
+          <a:p/>
+          <a:p>
+            <a:r>
+              <a:t>"Each step is one of the five methods the challenge names. Training, mentoring, certification, job rotation, project experience."</a:t>
             </a:r>
           </a:p>
         </p:txBody>
@@ -795,11 +824,19 @@
           <a:lstStyle/>
           <a:p>
             <a:r>
-              <a:rPr lang="en-US" dirty="0"/>
-              <a:t>2:00 to 2:30  THE EMPLOYEE
-"The challenge says employees close skill gaps, so one screen is built for the employee, not only about them."
-"Sam is a refrigeration tech at Marshall, fourteen years in. He is one of two people who hold the ammonia certification, so his step is to pass it on. He ticks the same box his manager sees."
-If demoing: tick the box, show the counter go to one, then say the next line.</a:t>
+              <a:t>2:00 to 2:30  THE EMPLOYEE</a:t>
+            </a:r>
+          </a:p>
+          <a:p/>
+          <a:p>
+            <a:r>
+              <a:t>"The challenge says employees close skill gaps, so one screen is built for the employee, not only about them."</a:t>
+            </a:r>
+          </a:p>
+          <a:p/>
+          <a:p>
+            <a:r>
+              <a:t>"Sam is a refrigeration tech at Marshall, fourteen years in. He is one of two people who hold the ammonia certification, so his step is to pass it on. He ticks the same box his manager sees."</a:t>
             </a:r>
           </a:p>
         </p:txBody>
@@ -885,13 +922,31 @@
           <a:lstStyle/>
           <a:p>
             <a:r>
-              <a:rPr lang="en-US" dirty="0"/>
-              <a:t>2:30 to 3:00  CLOSE, then leave this slide up for questions
-"It is four files. Plain HTML, CSS and JavaScript. No framework, no build step, and nothing loads from the internet, so it cannot break on a bad venue network."
-"Every outside number is sourced. Three claims got cut during a fact check because I could only trace them to blogs."
-"Happy to take questions. These four are the ones I expect."
-Leave this slide up. It is your prompt sheet: the four answers are on it.
-If asked something not here: "I do not know, and I would rather find out than guess."</a:t>
+              <a:t>2:30 to 3:00  CLOSE, then leave this slide up for questions</a:t>
+            </a:r>
+          </a:p>
+          <a:p/>
+          <a:p>
+            <a:r>
+              <a:t>"It is four files. Plain HTML, CSS and JavaScript. No framework, no build step, and nothing loads from the internet, so it cannot break on a bad venue network."</a:t>
+            </a:r>
+          </a:p>
+          <a:p/>
+          <a:p>
+            <a:r>
+              <a:t>"Every outside number is sourced. Three claims got cut during a fact check because I could only trace them to blogs."</a:t>
+            </a:r>
+          </a:p>
+          <a:p/>
+          <a:p>
+            <a:r>
+              <a:t>"Happy to take questions. These four are the ones I expect."</a:t>
+            </a:r>
+          </a:p>
+          <a:p/>
+          <a:p>
+            <a:r>
+              <a:t>If asked something not here: "I do not know, and I would rather find out than guess."</a:t>
             </a:r>
           </a:p>
         </p:txBody>
@@ -995,10 +1050,13 @@
           <a:lstStyle/>
           <a:p>
             <a:r>
-              <a:rPr lang="en-US" dirty="0"/>
-              <a:t>0:00 to 0:15  OPENER
-"SkillSight. It shows what skills Schwan's people have, where those skills are missing, and where one person leaving stops the work."
-Do not read the numbers out. Let them sit on the slide. Move on at fifteen seconds.</a:t>
+              <a:t>3:00  QUESTIONS</a:t>
+            </a:r>
+          </a:p>
+          <a:p/>
+          <a:p>
+            <a:r>
+              <a:t>Hold here. The four questions on the previous slide are the ones to expect.</a:t>
             </a:r>
           </a:p>
         </p:txBody>

</xml_diff>